<commit_message>
fixed chap02 && finished chap01 ppt
</commit_message>
<xml_diff>
--- a/Mastering-Concurrency-in-Python.pptx
+++ b/Mastering-Concurrency-in-Python.pptx
@@ -6,23 +6,27 @@
     <p:sldMasterId id="2147483651" r:id="rId2"/>
   </p:sldMasterIdLst>
   <p:notesMasterIdLst>
-    <p:notesMasterId r:id="rId6"/>
+    <p:notesMasterId r:id="rId10"/>
   </p:notesMasterIdLst>
   <p:sldIdLst>
     <p:sldId id="256" r:id="rId3"/>
     <p:sldId id="258" r:id="rId4"/>
     <p:sldId id="257" r:id="rId5"/>
+    <p:sldId id="259" r:id="rId6"/>
+    <p:sldId id="260" r:id="rId7"/>
+    <p:sldId id="261" r:id="rId8"/>
+    <p:sldId id="262" r:id="rId9"/>
   </p:sldIdLst>
   <p:sldSz cx="12192000" cy="6858000"/>
   <p:notesSz cx="6858000" cy="12192000"/>
   <p:embeddedFontLst>
     <p:embeddedFont>
       <p:font typeface="Inter" panose="020B0604020202020204" charset="0"/>
-      <p:regular r:id="rId7"/>
+      <p:regular r:id="rId11"/>
     </p:embeddedFont>
     <p:embeddedFont>
       <p:font typeface="Inter Bold" panose="020B0604020202020204" charset="0"/>
-      <p:regular r:id="rId8"/>
+      <p:regular r:id="rId12"/>
     </p:embeddedFont>
   </p:embeddedFontLst>
   <p:defaultTextStyle>
@@ -661,6 +665,498 @@
     <p:extLst>
       <p:ext uri="{BB962C8B-B14F-4D97-AF65-F5344CB8AC3E}">
         <p14:creationId xmlns:p14="http://schemas.microsoft.com/office/powerpoint/2010/main" val="1024086991"/>
+      </p:ext>
+    </p:extLst>
+  </p:cSld>
+  <p:clrMapOvr>
+    <a:masterClrMapping/>
+  </p:clrMapOvr>
+</p:notes>
+</file>
+
+<file path=ppt/notesSlides/notesSlide4.xml><?xml version="1.0" encoding="utf-8"?>
+<p:notes xmlns:a="http://schemas.openxmlformats.org/drawingml/2006/main" xmlns:r="http://schemas.openxmlformats.org/officeDocument/2006/relationships" xmlns:p="http://schemas.openxmlformats.org/presentationml/2006/main">
+  <p:cSld>
+    <p:spTree>
+      <p:nvGrpSpPr>
+        <p:cNvPr id="1" name="">
+          <a:extLst>
+            <a:ext uri="{FF2B5EF4-FFF2-40B4-BE49-F238E27FC236}">
+              <a16:creationId xmlns:a16="http://schemas.microsoft.com/office/drawing/2014/main" id="{1C316014-ACAB-8F26-4123-7A1CC523DA2F}"/>
+            </a:ext>
+          </a:extLst>
+        </p:cNvPr>
+        <p:cNvGrpSpPr/>
+        <p:nvPr/>
+      </p:nvGrpSpPr>
+      <p:grpSpPr>
+        <a:xfrm>
+          <a:off x="0" y="0"/>
+          <a:ext cx="0" cy="0"/>
+          <a:chOff x="0" y="0"/>
+          <a:chExt cx="0" cy="0"/>
+        </a:xfrm>
+      </p:grpSpPr>
+      <p:sp>
+        <p:nvSpPr>
+          <p:cNvPr id="2" name="Slide Image Placeholder 1">
+            <a:extLst>
+              <a:ext uri="{FF2B5EF4-FFF2-40B4-BE49-F238E27FC236}">
+                <a16:creationId xmlns:a16="http://schemas.microsoft.com/office/drawing/2014/main" id="{89DF0671-E74F-AA40-1C42-C2BF6FB3B835}"/>
+              </a:ext>
+            </a:extLst>
+          </p:cNvPr>
+          <p:cNvSpPr>
+            <a:spLocks noGrp="1" noRot="1" noChangeAspect="1"/>
+          </p:cNvSpPr>
+          <p:nvPr>
+            <p:ph type="sldImg"/>
+          </p:nvPr>
+        </p:nvSpPr>
+        <p:spPr/>
+      </p:sp>
+      <p:sp>
+        <p:nvSpPr>
+          <p:cNvPr id="3" name="Notes Placeholder 2">
+            <a:extLst>
+              <a:ext uri="{FF2B5EF4-FFF2-40B4-BE49-F238E27FC236}">
+                <a16:creationId xmlns:a16="http://schemas.microsoft.com/office/drawing/2014/main" id="{493DBCB0-8D88-B785-A016-CEB356BCE2A3}"/>
+              </a:ext>
+            </a:extLst>
+          </p:cNvPr>
+          <p:cNvSpPr>
+            <a:spLocks noGrp="1"/>
+          </p:cNvSpPr>
+          <p:nvPr>
+            <p:ph type="body" idx="1"/>
+          </p:nvPr>
+        </p:nvSpPr>
+        <p:spPr/>
+        <p:txBody>
+          <a:bodyPr/>
+          <a:lstStyle/>
+          <a:p>
+            <a:endParaRPr lang="en-US" dirty="0"/>
+          </a:p>
+        </p:txBody>
+      </p:sp>
+      <p:sp>
+        <p:nvSpPr>
+          <p:cNvPr id="4" name="Slide Number Placeholder 3">
+            <a:extLst>
+              <a:ext uri="{FF2B5EF4-FFF2-40B4-BE49-F238E27FC236}">
+                <a16:creationId xmlns:a16="http://schemas.microsoft.com/office/drawing/2014/main" id="{FD5BDA46-D825-392F-CE1A-7A722D6411C5}"/>
+              </a:ext>
+            </a:extLst>
+          </p:cNvPr>
+          <p:cNvSpPr>
+            <a:spLocks noGrp="1"/>
+          </p:cNvSpPr>
+          <p:nvPr>
+            <p:ph type="sldNum" sz="quarter" idx="10"/>
+          </p:nvPr>
+        </p:nvSpPr>
+        <p:spPr/>
+        <p:txBody>
+          <a:bodyPr/>
+          <a:lstStyle/>
+          <a:p>
+            <a:fld id="{F7021451-1387-4CA6-816F-3879F97B5CBC}" type="slidenum">
+              <a:rPr lang="en-US"/>
+              <a:t>4</a:t>
+            </a:fld>
+            <a:endParaRPr lang="en-US"/>
+          </a:p>
+        </p:txBody>
+      </p:sp>
+    </p:spTree>
+    <p:extLst>
+      <p:ext uri="{BB962C8B-B14F-4D97-AF65-F5344CB8AC3E}">
+        <p14:creationId xmlns:p14="http://schemas.microsoft.com/office/powerpoint/2010/main" val="2126713297"/>
+      </p:ext>
+    </p:extLst>
+  </p:cSld>
+  <p:clrMapOvr>
+    <a:masterClrMapping/>
+  </p:clrMapOvr>
+</p:notes>
+</file>
+
+<file path=ppt/notesSlides/notesSlide5.xml><?xml version="1.0" encoding="utf-8"?>
+<p:notes xmlns:a="http://schemas.openxmlformats.org/drawingml/2006/main" xmlns:r="http://schemas.openxmlformats.org/officeDocument/2006/relationships" xmlns:p="http://schemas.openxmlformats.org/presentationml/2006/main">
+  <p:cSld>
+    <p:spTree>
+      <p:nvGrpSpPr>
+        <p:cNvPr id="1" name="">
+          <a:extLst>
+            <a:ext uri="{FF2B5EF4-FFF2-40B4-BE49-F238E27FC236}">
+              <a16:creationId xmlns:a16="http://schemas.microsoft.com/office/drawing/2014/main" id="{7733D6BA-C708-06C5-E74A-574ACCDB4160}"/>
+            </a:ext>
+          </a:extLst>
+        </p:cNvPr>
+        <p:cNvGrpSpPr/>
+        <p:nvPr/>
+      </p:nvGrpSpPr>
+      <p:grpSpPr>
+        <a:xfrm>
+          <a:off x="0" y="0"/>
+          <a:ext cx="0" cy="0"/>
+          <a:chOff x="0" y="0"/>
+          <a:chExt cx="0" cy="0"/>
+        </a:xfrm>
+      </p:grpSpPr>
+      <p:sp>
+        <p:nvSpPr>
+          <p:cNvPr id="2" name="Slide Image Placeholder 1">
+            <a:extLst>
+              <a:ext uri="{FF2B5EF4-FFF2-40B4-BE49-F238E27FC236}">
+                <a16:creationId xmlns:a16="http://schemas.microsoft.com/office/drawing/2014/main" id="{26CEE369-7700-8832-4867-749D2FA9FDFE}"/>
+              </a:ext>
+            </a:extLst>
+          </p:cNvPr>
+          <p:cNvSpPr>
+            <a:spLocks noGrp="1" noRot="1" noChangeAspect="1"/>
+          </p:cNvSpPr>
+          <p:nvPr>
+            <p:ph type="sldImg"/>
+          </p:nvPr>
+        </p:nvSpPr>
+        <p:spPr/>
+      </p:sp>
+      <p:sp>
+        <p:nvSpPr>
+          <p:cNvPr id="3" name="Notes Placeholder 2">
+            <a:extLst>
+              <a:ext uri="{FF2B5EF4-FFF2-40B4-BE49-F238E27FC236}">
+                <a16:creationId xmlns:a16="http://schemas.microsoft.com/office/drawing/2014/main" id="{9C6E49F5-D609-91D7-A949-A155BFB2A408}"/>
+              </a:ext>
+            </a:extLst>
+          </p:cNvPr>
+          <p:cNvSpPr>
+            <a:spLocks noGrp="1"/>
+          </p:cNvSpPr>
+          <p:nvPr>
+            <p:ph type="body" idx="1"/>
+          </p:nvPr>
+        </p:nvSpPr>
+        <p:spPr/>
+        <p:txBody>
+          <a:bodyPr/>
+          <a:lstStyle/>
+          <a:p>
+            <a:endParaRPr lang="en-US" dirty="0"/>
+          </a:p>
+        </p:txBody>
+      </p:sp>
+      <p:sp>
+        <p:nvSpPr>
+          <p:cNvPr id="4" name="Slide Number Placeholder 3">
+            <a:extLst>
+              <a:ext uri="{FF2B5EF4-FFF2-40B4-BE49-F238E27FC236}">
+                <a16:creationId xmlns:a16="http://schemas.microsoft.com/office/drawing/2014/main" id="{D4E2322F-F894-B2D7-14D5-BAE47466789D}"/>
+              </a:ext>
+            </a:extLst>
+          </p:cNvPr>
+          <p:cNvSpPr>
+            <a:spLocks noGrp="1"/>
+          </p:cNvSpPr>
+          <p:nvPr>
+            <p:ph type="sldNum" sz="quarter" idx="10"/>
+          </p:nvPr>
+        </p:nvSpPr>
+        <p:spPr/>
+        <p:txBody>
+          <a:bodyPr/>
+          <a:lstStyle/>
+          <a:p>
+            <a:fld id="{F7021451-1387-4CA6-816F-3879F97B5CBC}" type="slidenum">
+              <a:rPr lang="en-US"/>
+              <a:t>5</a:t>
+            </a:fld>
+            <a:endParaRPr lang="en-US"/>
+          </a:p>
+        </p:txBody>
+      </p:sp>
+    </p:spTree>
+    <p:extLst>
+      <p:ext uri="{BB962C8B-B14F-4D97-AF65-F5344CB8AC3E}">
+        <p14:creationId xmlns:p14="http://schemas.microsoft.com/office/powerpoint/2010/main" val="55095523"/>
+      </p:ext>
+    </p:extLst>
+  </p:cSld>
+  <p:clrMapOvr>
+    <a:masterClrMapping/>
+  </p:clrMapOvr>
+</p:notes>
+</file>
+
+<file path=ppt/notesSlides/notesSlide6.xml><?xml version="1.0" encoding="utf-8"?>
+<p:notes xmlns:a="http://schemas.openxmlformats.org/drawingml/2006/main" xmlns:r="http://schemas.openxmlformats.org/officeDocument/2006/relationships" xmlns:p="http://schemas.openxmlformats.org/presentationml/2006/main">
+  <p:cSld>
+    <p:spTree>
+      <p:nvGrpSpPr>
+        <p:cNvPr id="1" name="">
+          <a:extLst>
+            <a:ext uri="{FF2B5EF4-FFF2-40B4-BE49-F238E27FC236}">
+              <a16:creationId xmlns:a16="http://schemas.microsoft.com/office/drawing/2014/main" id="{193AA25D-6982-B5E7-D7F3-43AF7306C062}"/>
+            </a:ext>
+          </a:extLst>
+        </p:cNvPr>
+        <p:cNvGrpSpPr/>
+        <p:nvPr/>
+      </p:nvGrpSpPr>
+      <p:grpSpPr>
+        <a:xfrm>
+          <a:off x="0" y="0"/>
+          <a:ext cx="0" cy="0"/>
+          <a:chOff x="0" y="0"/>
+          <a:chExt cx="0" cy="0"/>
+        </a:xfrm>
+      </p:grpSpPr>
+      <p:sp>
+        <p:nvSpPr>
+          <p:cNvPr id="2" name="Slide Image Placeholder 1">
+            <a:extLst>
+              <a:ext uri="{FF2B5EF4-FFF2-40B4-BE49-F238E27FC236}">
+                <a16:creationId xmlns:a16="http://schemas.microsoft.com/office/drawing/2014/main" id="{1B17B417-D100-E1C6-A6BD-5C0E95A18C6B}"/>
+              </a:ext>
+            </a:extLst>
+          </p:cNvPr>
+          <p:cNvSpPr>
+            <a:spLocks noGrp="1" noRot="1" noChangeAspect="1"/>
+          </p:cNvSpPr>
+          <p:nvPr>
+            <p:ph type="sldImg"/>
+          </p:nvPr>
+        </p:nvSpPr>
+        <p:spPr/>
+      </p:sp>
+      <p:sp>
+        <p:nvSpPr>
+          <p:cNvPr id="3" name="Notes Placeholder 2">
+            <a:extLst>
+              <a:ext uri="{FF2B5EF4-FFF2-40B4-BE49-F238E27FC236}">
+                <a16:creationId xmlns:a16="http://schemas.microsoft.com/office/drawing/2014/main" id="{21443D7E-F971-3B06-6B66-008A21FF67A7}"/>
+              </a:ext>
+            </a:extLst>
+          </p:cNvPr>
+          <p:cNvSpPr>
+            <a:spLocks noGrp="1"/>
+          </p:cNvSpPr>
+          <p:nvPr>
+            <p:ph type="body" idx="1"/>
+          </p:nvPr>
+        </p:nvSpPr>
+        <p:spPr/>
+        <p:txBody>
+          <a:bodyPr/>
+          <a:lstStyle/>
+          <a:p>
+            <a:endParaRPr lang="en-US" dirty="0"/>
+          </a:p>
+        </p:txBody>
+      </p:sp>
+      <p:sp>
+        <p:nvSpPr>
+          <p:cNvPr id="4" name="Slide Number Placeholder 3">
+            <a:extLst>
+              <a:ext uri="{FF2B5EF4-FFF2-40B4-BE49-F238E27FC236}">
+                <a16:creationId xmlns:a16="http://schemas.microsoft.com/office/drawing/2014/main" id="{27DB5F15-BC88-73DD-52FF-0CCE11C6A2BF}"/>
+              </a:ext>
+            </a:extLst>
+          </p:cNvPr>
+          <p:cNvSpPr>
+            <a:spLocks noGrp="1"/>
+          </p:cNvSpPr>
+          <p:nvPr>
+            <p:ph type="sldNum" sz="quarter" idx="10"/>
+          </p:nvPr>
+        </p:nvSpPr>
+        <p:spPr/>
+        <p:txBody>
+          <a:bodyPr/>
+          <a:lstStyle/>
+          <a:p>
+            <a:pPr marL="0" marR="0" lvl="0" indent="0" algn="l" defTabSz="914400" rtl="0" eaLnBrk="1" fontAlgn="auto" latinLnBrk="0" hangingPunct="1">
+              <a:lnSpc>
+                <a:spcPct val="100000"/>
+              </a:lnSpc>
+              <a:spcBef>
+                <a:spcPts val="0"/>
+              </a:spcBef>
+              <a:spcAft>
+                <a:spcPts val="0"/>
+              </a:spcAft>
+              <a:buClrTx/>
+              <a:buSzTx/>
+              <a:buFontTx/>
+              <a:buNone/>
+              <a:tabLst/>
+              <a:defRPr/>
+            </a:pPr>
+            <a:fld id="{F7021451-1387-4CA6-816F-3879F97B5CBC}" type="slidenum">
+              <a:rPr kumimoji="0" lang="en-US" sz="1800" b="0" i="0" u="none" strike="noStrike" kern="1200" cap="none" spc="0" normalizeH="0" baseline="0" noProof="0">
+                <a:ln>
+                  <a:noFill/>
+                </a:ln>
+                <a:solidFill>
+                  <a:prstClr val="black"/>
+                </a:solidFill>
+                <a:effectLst/>
+                <a:uLnTx/>
+                <a:uFillTx/>
+                <a:latin typeface="Aptos" panose="02110004020202020204"/>
+                <a:ea typeface="+mn-ea"/>
+                <a:cs typeface="+mn-cs"/>
+              </a:rPr>
+              <a:pPr marL="0" marR="0" lvl="0" indent="0" algn="l" defTabSz="914400" rtl="0" eaLnBrk="1" fontAlgn="auto" latinLnBrk="0" hangingPunct="1">
+                <a:lnSpc>
+                  <a:spcPct val="100000"/>
+                </a:lnSpc>
+                <a:spcBef>
+                  <a:spcPts val="0"/>
+                </a:spcBef>
+                <a:spcAft>
+                  <a:spcPts val="0"/>
+                </a:spcAft>
+                <a:buClrTx/>
+                <a:buSzTx/>
+                <a:buFontTx/>
+                <a:buNone/>
+                <a:tabLst/>
+                <a:defRPr/>
+              </a:pPr>
+              <a:t>6</a:t>
+            </a:fld>
+            <a:endParaRPr kumimoji="0" lang="en-US" sz="1800" b="0" i="0" u="none" strike="noStrike" kern="1200" cap="none" spc="0" normalizeH="0" baseline="0" noProof="0">
+              <a:ln>
+                <a:noFill/>
+              </a:ln>
+              <a:solidFill>
+                <a:prstClr val="black"/>
+              </a:solidFill>
+              <a:effectLst/>
+              <a:uLnTx/>
+              <a:uFillTx/>
+              <a:latin typeface="Aptos" panose="02110004020202020204"/>
+              <a:ea typeface="+mn-ea"/>
+              <a:cs typeface="+mn-cs"/>
+            </a:endParaRPr>
+          </a:p>
+        </p:txBody>
+      </p:sp>
+    </p:spTree>
+    <p:extLst>
+      <p:ext uri="{BB962C8B-B14F-4D97-AF65-F5344CB8AC3E}">
+        <p14:creationId xmlns:p14="http://schemas.microsoft.com/office/powerpoint/2010/main" val="2560781352"/>
+      </p:ext>
+    </p:extLst>
+  </p:cSld>
+  <p:clrMapOvr>
+    <a:masterClrMapping/>
+  </p:clrMapOvr>
+</p:notes>
+</file>
+
+<file path=ppt/notesSlides/notesSlide7.xml><?xml version="1.0" encoding="utf-8"?>
+<p:notes xmlns:a="http://schemas.openxmlformats.org/drawingml/2006/main" xmlns:r="http://schemas.openxmlformats.org/officeDocument/2006/relationships" xmlns:p="http://schemas.openxmlformats.org/presentationml/2006/main">
+  <p:cSld>
+    <p:spTree>
+      <p:nvGrpSpPr>
+        <p:cNvPr id="1" name="">
+          <a:extLst>
+            <a:ext uri="{FF2B5EF4-FFF2-40B4-BE49-F238E27FC236}">
+              <a16:creationId xmlns:a16="http://schemas.microsoft.com/office/drawing/2014/main" id="{6E035C1D-0B24-E4CD-3806-23BF992EADFD}"/>
+            </a:ext>
+          </a:extLst>
+        </p:cNvPr>
+        <p:cNvGrpSpPr/>
+        <p:nvPr/>
+      </p:nvGrpSpPr>
+      <p:grpSpPr>
+        <a:xfrm>
+          <a:off x="0" y="0"/>
+          <a:ext cx="0" cy="0"/>
+          <a:chOff x="0" y="0"/>
+          <a:chExt cx="0" cy="0"/>
+        </a:xfrm>
+      </p:grpSpPr>
+      <p:sp>
+        <p:nvSpPr>
+          <p:cNvPr id="2" name="Slide Image Placeholder 1">
+            <a:extLst>
+              <a:ext uri="{FF2B5EF4-FFF2-40B4-BE49-F238E27FC236}">
+                <a16:creationId xmlns:a16="http://schemas.microsoft.com/office/drawing/2014/main" id="{B0C90A71-F9A3-96C2-CAA5-3154921B50C7}"/>
+              </a:ext>
+            </a:extLst>
+          </p:cNvPr>
+          <p:cNvSpPr>
+            <a:spLocks noGrp="1" noRot="1" noChangeAspect="1"/>
+          </p:cNvSpPr>
+          <p:nvPr>
+            <p:ph type="sldImg"/>
+          </p:nvPr>
+        </p:nvSpPr>
+        <p:spPr/>
+      </p:sp>
+      <p:sp>
+        <p:nvSpPr>
+          <p:cNvPr id="3" name="Notes Placeholder 2">
+            <a:extLst>
+              <a:ext uri="{FF2B5EF4-FFF2-40B4-BE49-F238E27FC236}">
+                <a16:creationId xmlns:a16="http://schemas.microsoft.com/office/drawing/2014/main" id="{5EE1F54C-25FB-72DD-BA0C-5E3FCE2F7970}"/>
+              </a:ext>
+            </a:extLst>
+          </p:cNvPr>
+          <p:cNvSpPr>
+            <a:spLocks noGrp="1"/>
+          </p:cNvSpPr>
+          <p:nvPr>
+            <p:ph type="body" idx="1"/>
+          </p:nvPr>
+        </p:nvSpPr>
+        <p:spPr/>
+        <p:txBody>
+          <a:bodyPr/>
+          <a:lstStyle/>
+          <a:p>
+            <a:endParaRPr lang="en-US" dirty="0"/>
+          </a:p>
+        </p:txBody>
+      </p:sp>
+      <p:sp>
+        <p:nvSpPr>
+          <p:cNvPr id="4" name="Slide Number Placeholder 3">
+            <a:extLst>
+              <a:ext uri="{FF2B5EF4-FFF2-40B4-BE49-F238E27FC236}">
+                <a16:creationId xmlns:a16="http://schemas.microsoft.com/office/drawing/2014/main" id="{61827A4F-A9C6-89EB-7587-E803D3694EF3}"/>
+              </a:ext>
+            </a:extLst>
+          </p:cNvPr>
+          <p:cNvSpPr>
+            <a:spLocks noGrp="1"/>
+          </p:cNvSpPr>
+          <p:nvPr>
+            <p:ph type="sldNum" sz="quarter" idx="10"/>
+          </p:nvPr>
+        </p:nvSpPr>
+        <p:spPr/>
+        <p:txBody>
+          <a:bodyPr/>
+          <a:lstStyle/>
+          <a:p>
+            <a:fld id="{F7021451-1387-4CA6-816F-3879F97B5CBC}" type="slidenum">
+              <a:rPr lang="en-US"/>
+              <a:t>7</a:t>
+            </a:fld>
+            <a:endParaRPr lang="en-US"/>
+          </a:p>
+        </p:txBody>
+      </p:sp>
+    </p:spTree>
+    <p:extLst>
+      <p:ext uri="{BB962C8B-B14F-4D97-AF65-F5344CB8AC3E}">
+        <p14:creationId xmlns:p14="http://schemas.microsoft.com/office/powerpoint/2010/main" val="2695840818"/>
       </p:ext>
     </p:extLst>
   </p:cSld>
@@ -3002,6 +3498,2539 @@
 </p:sld>
 </file>
 
+<file path=ppt/slides/slide4.xml><?xml version="1.0" encoding="utf-8"?>
+<p:sld xmlns:a="http://schemas.openxmlformats.org/drawingml/2006/main" xmlns:r="http://schemas.openxmlformats.org/officeDocument/2006/relationships" xmlns:p="http://schemas.openxmlformats.org/presentationml/2006/main">
+  <p:cSld>
+    <p:spTree>
+      <p:nvGrpSpPr>
+        <p:cNvPr id="1" name="">
+          <a:extLst>
+            <a:ext uri="{FF2B5EF4-FFF2-40B4-BE49-F238E27FC236}">
+              <a16:creationId xmlns:a16="http://schemas.microsoft.com/office/drawing/2014/main" id="{9BAF6947-0DB1-8F73-A241-933DB101AC39}"/>
+            </a:ext>
+          </a:extLst>
+        </p:cNvPr>
+        <p:cNvGrpSpPr/>
+        <p:nvPr/>
+      </p:nvGrpSpPr>
+      <p:grpSpPr>
+        <a:xfrm>
+          <a:off x="0" y="0"/>
+          <a:ext cx="0" cy="0"/>
+          <a:chOff x="0" y="0"/>
+          <a:chExt cx="0" cy="0"/>
+        </a:xfrm>
+      </p:grpSpPr>
+      <p:sp>
+        <p:nvSpPr>
+          <p:cNvPr id="2" name="Text 0">
+            <a:extLst>
+              <a:ext uri="{FF2B5EF4-FFF2-40B4-BE49-F238E27FC236}">
+                <a16:creationId xmlns:a16="http://schemas.microsoft.com/office/drawing/2014/main" id="{7709EC80-45E3-6A4E-E56F-20AE34EFB419}"/>
+              </a:ext>
+            </a:extLst>
+          </p:cNvPr>
+          <p:cNvSpPr/>
+          <p:nvPr/>
+        </p:nvSpPr>
+        <p:spPr>
+          <a:xfrm>
+            <a:off x="661475" y="522387"/>
+            <a:ext cx="10868745" cy="406995"/>
+          </a:xfrm>
+          <a:prstGeom prst="rect">
+            <a:avLst/>
+          </a:prstGeom>
+          <a:noFill/>
+          <a:ln/>
+        </p:spPr>
+        <p:txBody>
+          <a:bodyPr wrap="none" lIns="0" tIns="0" rIns="0" bIns="0" rtlCol="0" anchor="t"/>
+          <a:lstStyle/>
+          <a:p>
+            <a:pPr marL="0" indent="0" algn="l">
+              <a:lnSpc>
+                <a:spcPct val="104000"/>
+              </a:lnSpc>
+              <a:buNone/>
+            </a:pPr>
+            <a:r>
+              <a:rPr lang="en-US" sz="2550" b="1" dirty="0">
+                <a:solidFill>
+                  <a:srgbClr val="002F6B"/>
+                </a:solidFill>
+                <a:latin typeface="Inter Bold" pitchFamily="34" charset="0"/>
+                <a:ea typeface="Inter Bold" pitchFamily="34" charset="-122"/>
+                <a:cs typeface="Inter Bold" pitchFamily="34" charset="-120"/>
+              </a:rPr>
+              <a:t>Question</a:t>
+            </a:r>
+            <a:endParaRPr lang="en-US" sz="2550" dirty="0"/>
+          </a:p>
+        </p:txBody>
+      </p:sp>
+      <p:grpSp>
+        <p:nvGrpSpPr>
+          <p:cNvPr id="36" name="Group 35">
+            <a:extLst>
+              <a:ext uri="{FF2B5EF4-FFF2-40B4-BE49-F238E27FC236}">
+                <a16:creationId xmlns:a16="http://schemas.microsoft.com/office/drawing/2014/main" id="{150F892F-9371-558A-9BDC-DBD812A349B5}"/>
+              </a:ext>
+            </a:extLst>
+          </p:cNvPr>
+          <p:cNvGrpSpPr/>
+          <p:nvPr/>
+        </p:nvGrpSpPr>
+        <p:grpSpPr>
+          <a:xfrm>
+            <a:off x="661475" y="1117495"/>
+            <a:ext cx="6731363" cy="673587"/>
+            <a:chOff x="661475" y="1117495"/>
+            <a:chExt cx="6731363" cy="673587"/>
+          </a:xfrm>
+        </p:grpSpPr>
+        <p:sp>
+          <p:nvSpPr>
+            <p:cNvPr id="3" name="Text 1">
+              <a:extLst>
+                <a:ext uri="{FF2B5EF4-FFF2-40B4-BE49-F238E27FC236}">
+                  <a16:creationId xmlns:a16="http://schemas.microsoft.com/office/drawing/2014/main" id="{3BCDD130-656D-CD51-4ED6-7A730CD35B2E}"/>
+                </a:ext>
+              </a:extLst>
+            </p:cNvPr>
+            <p:cNvSpPr/>
+            <p:nvPr/>
+          </p:nvSpPr>
+          <p:spPr>
+            <a:xfrm>
+              <a:off x="661475" y="1117495"/>
+              <a:ext cx="5868721" cy="406996"/>
+            </a:xfrm>
+            <a:prstGeom prst="rect">
+              <a:avLst/>
+            </a:prstGeom>
+            <a:noFill/>
+            <a:ln/>
+          </p:spPr>
+          <p:txBody>
+            <a:bodyPr wrap="none" lIns="0" tIns="0" rIns="0" bIns="0" rtlCol="0" anchor="t"/>
+            <a:lstStyle/>
+            <a:p>
+              <a:pPr marL="285750" lvl="0" indent="-285750">
+                <a:buFont typeface="Arial" panose="020B0604020202020204" pitchFamily="34" charset="0"/>
+                <a:buChar char="•"/>
+              </a:pPr>
+              <a:r>
+                <a:rPr lang="en-US" dirty="0"/>
+                <a:t>What is the idea behind concurrency, and why is it useful?</a:t>
+              </a:r>
+            </a:p>
+            <a:p>
+              <a:pPr algn="l">
+                <a:lnSpc>
+                  <a:spcPct val="113000"/>
+                </a:lnSpc>
+              </a:pPr>
+              <a:endParaRPr lang="en-US" sz="1000" dirty="0"/>
+            </a:p>
+          </p:txBody>
+        </p:sp>
+        <p:grpSp>
+          <p:nvGrpSpPr>
+            <p:cNvPr id="14" name="Group 13">
+              <a:extLst>
+                <a:ext uri="{FF2B5EF4-FFF2-40B4-BE49-F238E27FC236}">
+                  <a16:creationId xmlns:a16="http://schemas.microsoft.com/office/drawing/2014/main" id="{9FFA3AA6-709F-9D4E-0233-1E8F4EA27584}"/>
+                </a:ext>
+              </a:extLst>
+            </p:cNvPr>
+            <p:cNvGrpSpPr/>
+            <p:nvPr/>
+          </p:nvGrpSpPr>
+          <p:grpSpPr>
+            <a:xfrm>
+              <a:off x="730487" y="1384086"/>
+              <a:ext cx="6662351" cy="406996"/>
+              <a:chOff x="6261043" y="2443460"/>
+              <a:chExt cx="5275527" cy="767655"/>
+            </a:xfrm>
+          </p:grpSpPr>
+          <p:pic>
+            <p:nvPicPr>
+              <p:cNvPr id="5" name="Image 1" descr="preencoded.png">
+                <a:extLst>
+                  <a:ext uri="{FF2B5EF4-FFF2-40B4-BE49-F238E27FC236}">
+                    <a16:creationId xmlns:a16="http://schemas.microsoft.com/office/drawing/2014/main" id="{2C5B49BB-2DCC-C33E-9A2E-0565F5DF3ECB}"/>
+                  </a:ext>
+                </a:extLst>
+              </p:cNvPr>
+              <p:cNvPicPr>
+                <a:picLocks noChangeAspect="1"/>
+              </p:cNvPicPr>
+              <p:nvPr/>
+            </p:nvPicPr>
+            <p:blipFill>
+              <a:blip>
+                <a:extLst>
+                  <a:ext uri="{96DAC541-7B7A-43D3-8B79-37D633B846F1}">
+                    <asvg:svgBlip xmlns:asvg="http://schemas.microsoft.com/office/drawing/2016/SVG/main" r:embed="rId3"/>
+                  </a:ext>
+                </a:extLst>
+              </a:blip>
+              <a:stretch>
+                <a:fillRect/>
+              </a:stretch>
+            </p:blipFill>
+            <p:spPr>
+              <a:xfrm>
+                <a:off x="6261043" y="2443460"/>
+                <a:ext cx="5275527" cy="767655"/>
+              </a:xfrm>
+              <a:prstGeom prst="rect">
+                <a:avLst/>
+              </a:prstGeom>
+            </p:spPr>
+          </p:pic>
+          <p:sp>
+            <p:nvSpPr>
+              <p:cNvPr id="6" name="Text 2">
+                <a:extLst>
+                  <a:ext uri="{FF2B5EF4-FFF2-40B4-BE49-F238E27FC236}">
+                    <a16:creationId xmlns:a16="http://schemas.microsoft.com/office/drawing/2014/main" id="{EDE2C012-4856-2624-8ABE-8392EC5D21B5}"/>
+                  </a:ext>
+                </a:extLst>
+              </p:cNvPr>
+              <p:cNvSpPr/>
+              <p:nvPr/>
+            </p:nvSpPr>
+            <p:spPr>
+              <a:xfrm>
+                <a:off x="6486462" y="2592685"/>
+                <a:ext cx="4900887" cy="203498"/>
+              </a:xfrm>
+              <a:prstGeom prst="rect">
+                <a:avLst/>
+              </a:prstGeom>
+              <a:noFill/>
+              <a:ln/>
+            </p:spPr>
+            <p:txBody>
+              <a:bodyPr wrap="none" lIns="0" tIns="0" rIns="0" bIns="0" rtlCol="0" anchor="t"/>
+              <a:lstStyle/>
+              <a:p>
+                <a:pPr marL="0" indent="0" algn="l">
+                  <a:lnSpc>
+                    <a:spcPct val="104000"/>
+                  </a:lnSpc>
+                  <a:buNone/>
+                </a:pPr>
+                <a:r>
+                  <a:rPr lang="zh-CN" altLang="en-US" sz="1250" b="1" dirty="0">
+                    <a:solidFill>
+                      <a:srgbClr val="005A9B"/>
+                    </a:solidFill>
+                    <a:latin typeface="Inter Bold" pitchFamily="34" charset="0"/>
+                  </a:rPr>
+                  <a:t>是指系统具有处理多个问题的能力，在同一个</a:t>
+                </a:r>
+                <a:r>
+                  <a:rPr lang="en-US" altLang="zh-CN" sz="1250" b="1" dirty="0">
+                    <a:solidFill>
+                      <a:srgbClr val="005A9B"/>
+                    </a:solidFill>
+                    <a:latin typeface="Inter Bold" pitchFamily="34" charset="0"/>
+                  </a:rPr>
+                  <a:t>core</a:t>
+                </a:r>
+                <a:r>
+                  <a:rPr lang="zh-CN" altLang="en-US" sz="1250" b="1" dirty="0">
+                    <a:solidFill>
+                      <a:srgbClr val="005A9B"/>
+                    </a:solidFill>
+                    <a:latin typeface="Inter Bold" pitchFamily="34" charset="0"/>
+                  </a:rPr>
+                  <a:t>上面 交替执行任务使其效率最大化</a:t>
+                </a:r>
+                <a:endParaRPr lang="en-US" sz="1250" dirty="0"/>
+              </a:p>
+            </p:txBody>
+          </p:sp>
+        </p:grpSp>
+      </p:grpSp>
+      <p:grpSp>
+        <p:nvGrpSpPr>
+          <p:cNvPr id="37" name="Group 36">
+            <a:extLst>
+              <a:ext uri="{FF2B5EF4-FFF2-40B4-BE49-F238E27FC236}">
+                <a16:creationId xmlns:a16="http://schemas.microsoft.com/office/drawing/2014/main" id="{CFD1E80D-932F-19C8-CACA-7ABC68E31184}"/>
+              </a:ext>
+            </a:extLst>
+          </p:cNvPr>
+          <p:cNvGrpSpPr/>
+          <p:nvPr/>
+        </p:nvGrpSpPr>
+        <p:grpSpPr>
+          <a:xfrm>
+            <a:off x="661475" y="1847669"/>
+            <a:ext cx="11478330" cy="1179125"/>
+            <a:chOff x="661475" y="1943482"/>
+            <a:chExt cx="11478330" cy="1179125"/>
+          </a:xfrm>
+        </p:grpSpPr>
+        <p:sp>
+          <p:nvSpPr>
+            <p:cNvPr id="18" name="Text 1">
+              <a:extLst>
+                <a:ext uri="{FF2B5EF4-FFF2-40B4-BE49-F238E27FC236}">
+                  <a16:creationId xmlns:a16="http://schemas.microsoft.com/office/drawing/2014/main" id="{D7B54425-9C0E-A557-705D-A2DAED56EA65}"/>
+                </a:ext>
+              </a:extLst>
+            </p:cNvPr>
+            <p:cNvSpPr/>
+            <p:nvPr/>
+          </p:nvSpPr>
+          <p:spPr>
+            <a:xfrm>
+              <a:off x="661475" y="1943482"/>
+              <a:ext cx="11478330" cy="406997"/>
+            </a:xfrm>
+            <a:prstGeom prst="rect">
+              <a:avLst/>
+            </a:prstGeom>
+            <a:noFill/>
+            <a:ln/>
+          </p:spPr>
+          <p:txBody>
+            <a:bodyPr wrap="none" lIns="0" tIns="0" rIns="0" bIns="0" rtlCol="0" anchor="t"/>
+            <a:lstStyle/>
+            <a:p>
+              <a:pPr marL="285750" lvl="0" indent="-285750">
+                <a:buFont typeface="Arial" panose="020B0604020202020204" pitchFamily="34" charset="0"/>
+                <a:buChar char="•"/>
+              </a:pPr>
+              <a:r>
+                <a:rPr lang="en-US" dirty="0"/>
+                <a:t>What are the differences between concurrent programming and sequential programming and parallel programming?</a:t>
+              </a:r>
+            </a:p>
+            <a:p>
+              <a:pPr marL="171450" indent="-171450" algn="l">
+                <a:lnSpc>
+                  <a:spcPct val="113000"/>
+                </a:lnSpc>
+                <a:buFont typeface="Arial" panose="020B0604020202020204" pitchFamily="34" charset="0"/>
+                <a:buChar char="•"/>
+              </a:pPr>
+              <a:endParaRPr lang="en-US" sz="1000" dirty="0"/>
+            </a:p>
+          </p:txBody>
+        </p:sp>
+        <p:grpSp>
+          <p:nvGrpSpPr>
+            <p:cNvPr id="27" name="Group 26">
+              <a:extLst>
+                <a:ext uri="{FF2B5EF4-FFF2-40B4-BE49-F238E27FC236}">
+                  <a16:creationId xmlns:a16="http://schemas.microsoft.com/office/drawing/2014/main" id="{5DD056DF-2FA5-13D7-0A83-ADFB2A014188}"/>
+                </a:ext>
+              </a:extLst>
+            </p:cNvPr>
+            <p:cNvGrpSpPr/>
+            <p:nvPr/>
+          </p:nvGrpSpPr>
+          <p:grpSpPr>
+            <a:xfrm>
+              <a:off x="730487" y="2257280"/>
+              <a:ext cx="11130834" cy="865327"/>
+              <a:chOff x="6261043" y="2443460"/>
+              <a:chExt cx="5275527" cy="767655"/>
+            </a:xfrm>
+          </p:grpSpPr>
+          <p:pic>
+            <p:nvPicPr>
+              <p:cNvPr id="28" name="Image 1" descr="preencoded.png">
+                <a:extLst>
+                  <a:ext uri="{FF2B5EF4-FFF2-40B4-BE49-F238E27FC236}">
+                    <a16:creationId xmlns:a16="http://schemas.microsoft.com/office/drawing/2014/main" id="{D89D9828-E67C-A746-5BAB-201B3B4AC29E}"/>
+                  </a:ext>
+                </a:extLst>
+              </p:cNvPr>
+              <p:cNvPicPr>
+                <a:picLocks noChangeAspect="1"/>
+              </p:cNvPicPr>
+              <p:nvPr/>
+            </p:nvPicPr>
+            <p:blipFill>
+              <a:blip>
+                <a:extLst>
+                  <a:ext uri="{96DAC541-7B7A-43D3-8B79-37D633B846F1}">
+                    <asvg:svgBlip xmlns:asvg="http://schemas.microsoft.com/office/drawing/2016/SVG/main" r:embed="rId3"/>
+                  </a:ext>
+                </a:extLst>
+              </a:blip>
+              <a:stretch>
+                <a:fillRect/>
+              </a:stretch>
+            </p:blipFill>
+            <p:spPr>
+              <a:xfrm>
+                <a:off x="6261043" y="2443460"/>
+                <a:ext cx="5275527" cy="767655"/>
+              </a:xfrm>
+              <a:prstGeom prst="rect">
+                <a:avLst/>
+              </a:prstGeom>
+            </p:spPr>
+          </p:pic>
+          <p:sp>
+            <p:nvSpPr>
+              <p:cNvPr id="29" name="Text 2">
+                <a:extLst>
+                  <a:ext uri="{FF2B5EF4-FFF2-40B4-BE49-F238E27FC236}">
+                    <a16:creationId xmlns:a16="http://schemas.microsoft.com/office/drawing/2014/main" id="{A851FA92-6487-9DE8-73DF-67799B183A8B}"/>
+                  </a:ext>
+                </a:extLst>
+              </p:cNvPr>
+              <p:cNvSpPr/>
+              <p:nvPr/>
+            </p:nvSpPr>
+            <p:spPr>
+              <a:xfrm>
+                <a:off x="6486462" y="2592685"/>
+                <a:ext cx="4900887" cy="203498"/>
+              </a:xfrm>
+              <a:prstGeom prst="rect">
+                <a:avLst/>
+              </a:prstGeom>
+              <a:noFill/>
+              <a:ln/>
+            </p:spPr>
+            <p:txBody>
+              <a:bodyPr wrap="none" lIns="0" tIns="0" rIns="0" bIns="0" rtlCol="0" anchor="t"/>
+              <a:lstStyle/>
+              <a:p>
+                <a:pPr>
+                  <a:lnSpc>
+                    <a:spcPct val="104000"/>
+                  </a:lnSpc>
+                </a:pPr>
+                <a:r>
+                  <a:rPr lang="en-US" altLang="zh-CN" sz="1250" b="1" dirty="0">
+                    <a:solidFill>
+                      <a:srgbClr val="005A9B"/>
+                    </a:solidFill>
+                    <a:latin typeface="Inter Bold" pitchFamily="34" charset="0"/>
+                  </a:rPr>
+                  <a:t>Sequential programming </a:t>
+                </a:r>
+                <a:r>
+                  <a:rPr lang="zh-CN" altLang="en-US" sz="1250" b="1" dirty="0">
+                    <a:solidFill>
+                      <a:srgbClr val="005A9B"/>
+                    </a:solidFill>
+                    <a:latin typeface="Inter Bold" pitchFamily="34" charset="0"/>
+                  </a:rPr>
+                  <a:t>是程序按照特定顺序执行。而</a:t>
+                </a:r>
+                <a:r>
+                  <a:rPr lang="en-US" altLang="zh-CN" sz="1250" b="1" dirty="0">
+                    <a:solidFill>
+                      <a:srgbClr val="005A9B"/>
+                    </a:solidFill>
+                    <a:latin typeface="Inter Bold" pitchFamily="34" charset="0"/>
+                  </a:rPr>
+                  <a:t>Parallel programming </a:t>
+                </a:r>
+                <a:r>
+                  <a:rPr lang="zh-CN" altLang="en-US" sz="1250" b="1" dirty="0">
+                    <a:solidFill>
+                      <a:srgbClr val="005A9B"/>
+                    </a:solidFill>
+                    <a:latin typeface="Inter Bold" pitchFamily="34" charset="0"/>
+                  </a:rPr>
+                  <a:t>和 </a:t>
+                </a:r>
+                <a:r>
+                  <a:rPr lang="en-US" altLang="zh-CN" sz="1250" b="1" dirty="0">
+                    <a:solidFill>
+                      <a:srgbClr val="005A9B"/>
+                    </a:solidFill>
+                    <a:latin typeface="Inter Bold" pitchFamily="34" charset="0"/>
+                  </a:rPr>
+                  <a:t>concurrent </a:t>
+                </a:r>
+                <a:r>
+                  <a:rPr lang="en-US" altLang="zh-CN" sz="1250" b="1" dirty="0" err="1">
+                    <a:solidFill>
+                      <a:srgbClr val="005A9B"/>
+                    </a:solidFill>
+                    <a:latin typeface="Inter Bold" pitchFamily="34" charset="0"/>
+                  </a:rPr>
+                  <a:t>progamming</a:t>
+                </a:r>
+                <a:r>
+                  <a:rPr lang="zh-CN" altLang="en-US" sz="1250" b="1" dirty="0">
+                    <a:solidFill>
+                      <a:srgbClr val="005A9B"/>
+                    </a:solidFill>
+                    <a:latin typeface="Inter Bold" pitchFamily="34" charset="0"/>
+                  </a:rPr>
+                  <a:t>是指系统拥有同时执行多个程序的能力。</a:t>
+                </a:r>
+                <a:endParaRPr lang="en-US" altLang="zh-CN" sz="1250" b="1" dirty="0">
+                  <a:solidFill>
+                    <a:srgbClr val="005A9B"/>
+                  </a:solidFill>
+                  <a:latin typeface="Inter Bold" pitchFamily="34" charset="0"/>
+                </a:endParaRPr>
+              </a:p>
+              <a:p>
+                <a:pPr>
+                  <a:lnSpc>
+                    <a:spcPct val="104000"/>
+                  </a:lnSpc>
+                </a:pPr>
+                <a:r>
+                  <a:rPr lang="zh-CN" altLang="en-US" sz="1250" b="1" dirty="0">
+                    <a:solidFill>
+                      <a:srgbClr val="005A9B"/>
+                    </a:solidFill>
+                    <a:latin typeface="Inter Bold" pitchFamily="34" charset="0"/>
+                  </a:rPr>
+                  <a:t>而</a:t>
+                </a:r>
+                <a:r>
+                  <a:rPr lang="en-US" altLang="zh-CN" sz="1250" b="1" dirty="0">
+                    <a:solidFill>
+                      <a:srgbClr val="005A9B"/>
+                    </a:solidFill>
+                    <a:latin typeface="Inter Bold" pitchFamily="34" charset="0"/>
+                  </a:rPr>
+                  <a:t>parallel program</a:t>
+                </a:r>
+                <a:r>
+                  <a:rPr lang="zh-CN" altLang="en-US" sz="1250" b="1" dirty="0">
+                    <a:solidFill>
+                      <a:srgbClr val="005A9B"/>
+                    </a:solidFill>
+                    <a:latin typeface="Inter Bold" pitchFamily="34" charset="0"/>
+                  </a:rPr>
+                  <a:t>和</a:t>
+                </a:r>
+                <a:r>
+                  <a:rPr lang="en-US" altLang="zh-CN" sz="1250" b="1" dirty="0">
+                    <a:solidFill>
+                      <a:srgbClr val="005A9B"/>
+                    </a:solidFill>
+                    <a:latin typeface="Inter Bold" pitchFamily="34" charset="0"/>
+                  </a:rPr>
+                  <a:t>concurrent </a:t>
+                </a:r>
+                <a:r>
+                  <a:rPr lang="en-US" altLang="zh-CN" sz="1250" b="1" dirty="0" err="1">
+                    <a:solidFill>
+                      <a:srgbClr val="005A9B"/>
+                    </a:solidFill>
+                    <a:latin typeface="Inter Bold" pitchFamily="34" charset="0"/>
+                  </a:rPr>
+                  <a:t>progam</a:t>
+                </a:r>
+                <a:r>
+                  <a:rPr lang="zh-CN" altLang="en-US" sz="1250" b="1" dirty="0">
+                    <a:solidFill>
+                      <a:srgbClr val="005A9B"/>
+                    </a:solidFill>
+                    <a:latin typeface="Inter Bold" pitchFamily="34" charset="0"/>
+                  </a:rPr>
+                  <a:t>的区别是 </a:t>
+                </a:r>
+                <a:r>
+                  <a:rPr lang="en-US" altLang="zh-CN" sz="1250" b="1" dirty="0">
+                    <a:solidFill>
+                      <a:srgbClr val="005A9B"/>
+                    </a:solidFill>
+                    <a:latin typeface="Inter Bold" pitchFamily="34" charset="0"/>
+                  </a:rPr>
+                  <a:t>parallel</a:t>
+                </a:r>
+                <a:r>
+                  <a:rPr lang="zh-CN" altLang="en-US" sz="1250" b="1" dirty="0">
+                    <a:solidFill>
+                      <a:srgbClr val="005A9B"/>
+                    </a:solidFill>
+                    <a:latin typeface="Inter Bold" pitchFamily="34" charset="0"/>
+                  </a:rPr>
+                  <a:t>能使用多个</a:t>
+                </a:r>
+                <a:r>
+                  <a:rPr lang="en-US" altLang="zh-CN" sz="1250" b="1" dirty="0">
+                    <a:solidFill>
+                      <a:srgbClr val="005A9B"/>
+                    </a:solidFill>
+                    <a:latin typeface="Inter Bold" pitchFamily="34" charset="0"/>
+                  </a:rPr>
+                  <a:t>core</a:t>
+                </a:r>
+                <a:r>
+                  <a:rPr lang="zh-CN" altLang="en-US" sz="1250" b="1" dirty="0">
+                    <a:solidFill>
+                      <a:srgbClr val="005A9B"/>
+                    </a:solidFill>
+                    <a:latin typeface="Inter Bold" pitchFamily="34" charset="0"/>
+                  </a:rPr>
+                  <a:t>去同时执行多个任务</a:t>
+                </a:r>
+                <a:endParaRPr lang="en-US" altLang="zh-CN" sz="1250" b="1" dirty="0">
+                  <a:solidFill>
+                    <a:srgbClr val="005A9B"/>
+                  </a:solidFill>
+                  <a:latin typeface="Inter Bold" pitchFamily="34" charset="0"/>
+                </a:endParaRPr>
+              </a:p>
+              <a:p>
+                <a:pPr>
+                  <a:lnSpc>
+                    <a:spcPct val="104000"/>
+                  </a:lnSpc>
+                </a:pPr>
+                <a:r>
+                  <a:rPr lang="zh-CN" altLang="en-US" sz="1250" b="1" dirty="0">
+                    <a:solidFill>
+                      <a:srgbClr val="005A9B"/>
+                    </a:solidFill>
+                    <a:latin typeface="Inter Bold" pitchFamily="34" charset="0"/>
+                  </a:rPr>
+                  <a:t>而</a:t>
+                </a:r>
+                <a:r>
+                  <a:rPr lang="en-US" altLang="zh-CN" sz="1250" b="1" dirty="0">
+                    <a:solidFill>
+                      <a:srgbClr val="005A9B"/>
+                    </a:solidFill>
+                    <a:latin typeface="Inter Bold" pitchFamily="34" charset="0"/>
+                  </a:rPr>
+                  <a:t>concurrent program</a:t>
+                </a:r>
+                <a:r>
+                  <a:rPr lang="zh-CN" altLang="en-US" sz="1250" b="1" dirty="0">
+                    <a:solidFill>
+                      <a:srgbClr val="005A9B"/>
+                    </a:solidFill>
+                    <a:latin typeface="Inter Bold" pitchFamily="34" charset="0"/>
+                  </a:rPr>
+                  <a:t>只能在单一</a:t>
+                </a:r>
+                <a:r>
+                  <a:rPr lang="en-US" altLang="zh-CN" sz="1250" b="1" dirty="0">
+                    <a:solidFill>
+                      <a:srgbClr val="005A9B"/>
+                    </a:solidFill>
+                    <a:latin typeface="Inter Bold" pitchFamily="34" charset="0"/>
+                  </a:rPr>
+                  <a:t>core</a:t>
+                </a:r>
+                <a:r>
+                  <a:rPr lang="zh-CN" altLang="en-US" sz="1250" b="1" dirty="0">
+                    <a:solidFill>
+                      <a:srgbClr val="005A9B"/>
+                    </a:solidFill>
+                    <a:latin typeface="Inter Bold" pitchFamily="34" charset="0"/>
+                  </a:rPr>
+                  <a:t>上面 交替执行任务</a:t>
+                </a:r>
+                <a:endParaRPr lang="en-US" sz="1250" dirty="0"/>
+              </a:p>
+            </p:txBody>
+          </p:sp>
+        </p:grpSp>
+      </p:grpSp>
+      <p:grpSp>
+        <p:nvGrpSpPr>
+          <p:cNvPr id="38" name="Group 37">
+            <a:extLst>
+              <a:ext uri="{FF2B5EF4-FFF2-40B4-BE49-F238E27FC236}">
+                <a16:creationId xmlns:a16="http://schemas.microsoft.com/office/drawing/2014/main" id="{A8351DC6-B22F-66F8-E73A-5C0658C441DD}"/>
+              </a:ext>
+            </a:extLst>
+          </p:cNvPr>
+          <p:cNvGrpSpPr/>
+          <p:nvPr/>
+        </p:nvGrpSpPr>
+        <p:grpSpPr>
+          <a:xfrm>
+            <a:off x="696041" y="3117037"/>
+            <a:ext cx="11504208" cy="726915"/>
+            <a:chOff x="787997" y="3210429"/>
+            <a:chExt cx="11504208" cy="726915"/>
+          </a:xfrm>
+        </p:grpSpPr>
+        <p:sp>
+          <p:nvSpPr>
+            <p:cNvPr id="22" name="Text 1">
+              <a:extLst>
+                <a:ext uri="{FF2B5EF4-FFF2-40B4-BE49-F238E27FC236}">
+                  <a16:creationId xmlns:a16="http://schemas.microsoft.com/office/drawing/2014/main" id="{CF5386B8-753A-730B-9378-645992338147}"/>
+                </a:ext>
+              </a:extLst>
+            </p:cNvPr>
+            <p:cNvSpPr/>
+            <p:nvPr/>
+          </p:nvSpPr>
+          <p:spPr>
+            <a:xfrm>
+              <a:off x="813875" y="3210429"/>
+              <a:ext cx="11478330" cy="351853"/>
+            </a:xfrm>
+            <a:prstGeom prst="rect">
+              <a:avLst/>
+            </a:prstGeom>
+            <a:noFill/>
+            <a:ln/>
+          </p:spPr>
+          <p:txBody>
+            <a:bodyPr wrap="none" lIns="0" tIns="0" rIns="0" bIns="0" rtlCol="0" anchor="t"/>
+            <a:lstStyle/>
+            <a:p>
+              <a:pPr marL="285750" lvl="0" indent="-285750">
+                <a:buFont typeface="Arial" panose="020B0604020202020204" pitchFamily="34" charset="0"/>
+                <a:buChar char="•"/>
+              </a:pPr>
+              <a:r>
+                <a:rPr lang="en-US" dirty="0"/>
+                <a:t>Can every program be made concurrent or parallel?</a:t>
+              </a:r>
+            </a:p>
+            <a:p>
+              <a:pPr marL="171450" indent="-171450" algn="l">
+                <a:lnSpc>
+                  <a:spcPct val="113000"/>
+                </a:lnSpc>
+                <a:buFont typeface="Arial" panose="020B0604020202020204" pitchFamily="34" charset="0"/>
+                <a:buChar char="•"/>
+              </a:pPr>
+              <a:endParaRPr lang="en-US" sz="1000" dirty="0"/>
+            </a:p>
+          </p:txBody>
+        </p:sp>
+        <p:grpSp>
+          <p:nvGrpSpPr>
+            <p:cNvPr id="30" name="Group 29">
+              <a:extLst>
+                <a:ext uri="{FF2B5EF4-FFF2-40B4-BE49-F238E27FC236}">
+                  <a16:creationId xmlns:a16="http://schemas.microsoft.com/office/drawing/2014/main" id="{487FE3C8-0BE8-6E63-949C-90F61E912CD7}"/>
+                </a:ext>
+              </a:extLst>
+            </p:cNvPr>
+            <p:cNvGrpSpPr/>
+            <p:nvPr/>
+          </p:nvGrpSpPr>
+          <p:grpSpPr>
+            <a:xfrm>
+              <a:off x="787997" y="3539742"/>
+              <a:ext cx="11130834" cy="397602"/>
+              <a:chOff x="6261043" y="2443460"/>
+              <a:chExt cx="5275527" cy="767655"/>
+            </a:xfrm>
+          </p:grpSpPr>
+          <p:pic>
+            <p:nvPicPr>
+              <p:cNvPr id="31" name="Image 1" descr="preencoded.png">
+                <a:extLst>
+                  <a:ext uri="{FF2B5EF4-FFF2-40B4-BE49-F238E27FC236}">
+                    <a16:creationId xmlns:a16="http://schemas.microsoft.com/office/drawing/2014/main" id="{A5F505FB-7047-1C08-D123-E0D230276DAA}"/>
+                  </a:ext>
+                </a:extLst>
+              </p:cNvPr>
+              <p:cNvPicPr>
+                <a:picLocks noChangeAspect="1"/>
+              </p:cNvPicPr>
+              <p:nvPr/>
+            </p:nvPicPr>
+            <p:blipFill>
+              <a:blip>
+                <a:extLst>
+                  <a:ext uri="{96DAC541-7B7A-43D3-8B79-37D633B846F1}">
+                    <asvg:svgBlip xmlns:asvg="http://schemas.microsoft.com/office/drawing/2016/SVG/main" r:embed="rId3"/>
+                  </a:ext>
+                </a:extLst>
+              </a:blip>
+              <a:stretch>
+                <a:fillRect/>
+              </a:stretch>
+            </p:blipFill>
+            <p:spPr>
+              <a:xfrm>
+                <a:off x="6261043" y="2443460"/>
+                <a:ext cx="5275527" cy="767655"/>
+              </a:xfrm>
+              <a:prstGeom prst="rect">
+                <a:avLst/>
+              </a:prstGeom>
+            </p:spPr>
+          </p:pic>
+          <p:sp>
+            <p:nvSpPr>
+              <p:cNvPr id="32" name="Text 2">
+                <a:extLst>
+                  <a:ext uri="{FF2B5EF4-FFF2-40B4-BE49-F238E27FC236}">
+                    <a16:creationId xmlns:a16="http://schemas.microsoft.com/office/drawing/2014/main" id="{4FDF5948-2454-05BA-09F9-E25F4F5F1BC0}"/>
+                  </a:ext>
+                </a:extLst>
+              </p:cNvPr>
+              <p:cNvSpPr/>
+              <p:nvPr/>
+            </p:nvSpPr>
+            <p:spPr>
+              <a:xfrm>
+                <a:off x="6486462" y="2592685"/>
+                <a:ext cx="4900887" cy="203498"/>
+              </a:xfrm>
+              <a:prstGeom prst="rect">
+                <a:avLst/>
+              </a:prstGeom>
+              <a:noFill/>
+              <a:ln/>
+            </p:spPr>
+            <p:txBody>
+              <a:bodyPr wrap="none" lIns="0" tIns="0" rIns="0" bIns="0" rtlCol="0" anchor="t"/>
+              <a:lstStyle/>
+              <a:p>
+                <a:pPr>
+                  <a:lnSpc>
+                    <a:spcPct val="104000"/>
+                  </a:lnSpc>
+                </a:pPr>
+                <a:r>
+                  <a:rPr lang="en-US" sz="1250" b="1" dirty="0">
+                    <a:solidFill>
+                      <a:srgbClr val="005A9B"/>
+                    </a:solidFill>
+                    <a:latin typeface="Inter Bold" pitchFamily="34" charset="0"/>
+                  </a:rPr>
+                  <a:t>Some tasks are naturally reply on other results. This type of programming inherently sequentially. </a:t>
+                </a:r>
+                <a:endParaRPr lang="en-US" sz="1250" dirty="0"/>
+              </a:p>
+            </p:txBody>
+          </p:sp>
+        </p:grpSp>
+      </p:grpSp>
+      <p:grpSp>
+        <p:nvGrpSpPr>
+          <p:cNvPr id="39" name="Group 38">
+            <a:extLst>
+              <a:ext uri="{FF2B5EF4-FFF2-40B4-BE49-F238E27FC236}">
+                <a16:creationId xmlns:a16="http://schemas.microsoft.com/office/drawing/2014/main" id="{1FA3F3BD-C1C1-3873-7F99-DE41368965EE}"/>
+              </a:ext>
+            </a:extLst>
+          </p:cNvPr>
+          <p:cNvGrpSpPr/>
+          <p:nvPr/>
+        </p:nvGrpSpPr>
+        <p:grpSpPr>
+          <a:xfrm>
+            <a:off x="696041" y="3996352"/>
+            <a:ext cx="11340423" cy="851595"/>
+            <a:chOff x="767870" y="4011002"/>
+            <a:chExt cx="11340423" cy="851595"/>
+          </a:xfrm>
+        </p:grpSpPr>
+        <p:sp>
+          <p:nvSpPr>
+            <p:cNvPr id="16" name="Text 1">
+              <a:extLst>
+                <a:ext uri="{FF2B5EF4-FFF2-40B4-BE49-F238E27FC236}">
+                  <a16:creationId xmlns:a16="http://schemas.microsoft.com/office/drawing/2014/main" id="{3158308A-F837-6AFD-5EBD-B72B307FBBB5}"/>
+                </a:ext>
+              </a:extLst>
+            </p:cNvPr>
+            <p:cNvSpPr/>
+            <p:nvPr/>
+          </p:nvSpPr>
+          <p:spPr>
+            <a:xfrm>
+              <a:off x="787997" y="4011002"/>
+              <a:ext cx="11320296" cy="329818"/>
+            </a:xfrm>
+            <a:prstGeom prst="rect">
+              <a:avLst/>
+            </a:prstGeom>
+            <a:noFill/>
+            <a:ln/>
+          </p:spPr>
+          <p:txBody>
+            <a:bodyPr wrap="none" lIns="0" tIns="0" rIns="0" bIns="0" rtlCol="0" anchor="t"/>
+            <a:lstStyle/>
+            <a:p>
+              <a:pPr marL="285750" lvl="0" indent="-285750">
+                <a:buFont typeface="Arial" panose="020B0604020202020204" pitchFamily="34" charset="0"/>
+                <a:buChar char="•"/>
+              </a:pPr>
+              <a:r>
+                <a:rPr lang="en-US" dirty="0"/>
+                <a:t>What are embarrassingly parallel tasks?</a:t>
+              </a:r>
+            </a:p>
+            <a:p>
+              <a:pPr marL="171450" indent="-171450" algn="l">
+                <a:lnSpc>
+                  <a:spcPct val="113000"/>
+                </a:lnSpc>
+                <a:buFont typeface="Arial" panose="020B0604020202020204" pitchFamily="34" charset="0"/>
+                <a:buChar char="•"/>
+              </a:pPr>
+              <a:endParaRPr lang="en-US" sz="1000" dirty="0"/>
+            </a:p>
+          </p:txBody>
+        </p:sp>
+        <p:grpSp>
+          <p:nvGrpSpPr>
+            <p:cNvPr id="33" name="Group 32">
+              <a:extLst>
+                <a:ext uri="{FF2B5EF4-FFF2-40B4-BE49-F238E27FC236}">
+                  <a16:creationId xmlns:a16="http://schemas.microsoft.com/office/drawing/2014/main" id="{C189015F-3FEF-C070-BD17-46E705068340}"/>
+                </a:ext>
+              </a:extLst>
+            </p:cNvPr>
+            <p:cNvGrpSpPr/>
+            <p:nvPr/>
+          </p:nvGrpSpPr>
+          <p:grpSpPr>
+            <a:xfrm>
+              <a:off x="767870" y="4304614"/>
+              <a:ext cx="11130834" cy="557983"/>
+              <a:chOff x="6261043" y="2443460"/>
+              <a:chExt cx="5275527" cy="767655"/>
+            </a:xfrm>
+          </p:grpSpPr>
+          <p:pic>
+            <p:nvPicPr>
+              <p:cNvPr id="34" name="Image 1" descr="preencoded.png">
+                <a:extLst>
+                  <a:ext uri="{FF2B5EF4-FFF2-40B4-BE49-F238E27FC236}">
+                    <a16:creationId xmlns:a16="http://schemas.microsoft.com/office/drawing/2014/main" id="{2BB2EA89-7F48-CA64-F67E-832044CE7B1F}"/>
+                  </a:ext>
+                </a:extLst>
+              </p:cNvPr>
+              <p:cNvPicPr>
+                <a:picLocks noChangeAspect="1"/>
+              </p:cNvPicPr>
+              <p:nvPr/>
+            </p:nvPicPr>
+            <p:blipFill>
+              <a:blip>
+                <a:extLst>
+                  <a:ext uri="{96DAC541-7B7A-43D3-8B79-37D633B846F1}">
+                    <asvg:svgBlip xmlns:asvg="http://schemas.microsoft.com/office/drawing/2016/SVG/main" r:embed="rId3"/>
+                  </a:ext>
+                </a:extLst>
+              </a:blip>
+              <a:stretch>
+                <a:fillRect/>
+              </a:stretch>
+            </p:blipFill>
+            <p:spPr>
+              <a:xfrm>
+                <a:off x="6261043" y="2443460"/>
+                <a:ext cx="5275527" cy="767655"/>
+              </a:xfrm>
+              <a:prstGeom prst="rect">
+                <a:avLst/>
+              </a:prstGeom>
+            </p:spPr>
+          </p:pic>
+          <p:sp>
+            <p:nvSpPr>
+              <p:cNvPr id="35" name="Text 2">
+                <a:extLst>
+                  <a:ext uri="{FF2B5EF4-FFF2-40B4-BE49-F238E27FC236}">
+                    <a16:creationId xmlns:a16="http://schemas.microsoft.com/office/drawing/2014/main" id="{9BDDCC45-FBEB-BE52-EB65-B031352BE684}"/>
+                  </a:ext>
+                </a:extLst>
+              </p:cNvPr>
+              <p:cNvSpPr/>
+              <p:nvPr/>
+            </p:nvSpPr>
+            <p:spPr>
+              <a:xfrm>
+                <a:off x="6486462" y="2592685"/>
+                <a:ext cx="4900887" cy="203498"/>
+              </a:xfrm>
+              <a:prstGeom prst="rect">
+                <a:avLst/>
+              </a:prstGeom>
+              <a:noFill/>
+              <a:ln/>
+            </p:spPr>
+            <p:txBody>
+              <a:bodyPr wrap="none" lIns="0" tIns="0" rIns="0" bIns="0" rtlCol="0" anchor="t"/>
+              <a:lstStyle/>
+              <a:p>
+                <a:pPr>
+                  <a:lnSpc>
+                    <a:spcPct val="104000"/>
+                  </a:lnSpc>
+                </a:pPr>
+                <a:r>
+                  <a:rPr lang="en-US" sz="1250" b="1" dirty="0">
+                    <a:solidFill>
+                      <a:srgbClr val="005A9B"/>
+                    </a:solidFill>
+                    <a:latin typeface="Inter Bold" pitchFamily="34" charset="0"/>
+                  </a:rPr>
+                  <a:t>Tasks can be split into independently sub-tasks, which have no/zero communication between them, like image processing; </a:t>
+                </a:r>
+              </a:p>
+              <a:p>
+                <a:pPr>
+                  <a:lnSpc>
+                    <a:spcPct val="104000"/>
+                  </a:lnSpc>
+                </a:pPr>
+                <a:r>
+                  <a:rPr lang="en-US" sz="1250" b="1" dirty="0">
+                    <a:solidFill>
+                      <a:srgbClr val="005A9B"/>
+                    </a:solidFill>
+                    <a:latin typeface="Inter Bold" pitchFamily="34" charset="0"/>
+                  </a:rPr>
+                  <a:t>3d video rendering;</a:t>
+                </a:r>
+                <a:endParaRPr lang="en-US" sz="1250" dirty="0"/>
+              </a:p>
+            </p:txBody>
+          </p:sp>
+        </p:grpSp>
+      </p:grpSp>
+    </p:spTree>
+    <p:extLst>
+      <p:ext uri="{BB962C8B-B14F-4D97-AF65-F5344CB8AC3E}">
+        <p14:creationId xmlns:p14="http://schemas.microsoft.com/office/powerpoint/2010/main" val="974629661"/>
+      </p:ext>
+    </p:extLst>
+  </p:cSld>
+  <p:clrMapOvr>
+    <a:masterClrMapping/>
+  </p:clrMapOvr>
+</p:sld>
+</file>
+
+<file path=ppt/slides/slide5.xml><?xml version="1.0" encoding="utf-8"?>
+<p:sld xmlns:a="http://schemas.openxmlformats.org/drawingml/2006/main" xmlns:r="http://schemas.openxmlformats.org/officeDocument/2006/relationships" xmlns:p="http://schemas.openxmlformats.org/presentationml/2006/main">
+  <p:cSld>
+    <p:spTree>
+      <p:nvGrpSpPr>
+        <p:cNvPr id="1" name="">
+          <a:extLst>
+            <a:ext uri="{FF2B5EF4-FFF2-40B4-BE49-F238E27FC236}">
+              <a16:creationId xmlns:a16="http://schemas.microsoft.com/office/drawing/2014/main" id="{050A74BF-AC77-4C5F-CA2B-B988FB090BAA}"/>
+            </a:ext>
+          </a:extLst>
+        </p:cNvPr>
+        <p:cNvGrpSpPr/>
+        <p:nvPr/>
+      </p:nvGrpSpPr>
+      <p:grpSpPr>
+        <a:xfrm>
+          <a:off x="0" y="0"/>
+          <a:ext cx="0" cy="0"/>
+          <a:chOff x="0" y="0"/>
+          <a:chExt cx="0" cy="0"/>
+        </a:xfrm>
+      </p:grpSpPr>
+      <p:sp>
+        <p:nvSpPr>
+          <p:cNvPr id="2" name="Text 0">
+            <a:extLst>
+              <a:ext uri="{FF2B5EF4-FFF2-40B4-BE49-F238E27FC236}">
+                <a16:creationId xmlns:a16="http://schemas.microsoft.com/office/drawing/2014/main" id="{35F3345F-AEB5-C955-C027-6073CDCD13BA}"/>
+              </a:ext>
+            </a:extLst>
+          </p:cNvPr>
+          <p:cNvSpPr/>
+          <p:nvPr/>
+        </p:nvSpPr>
+        <p:spPr>
+          <a:xfrm>
+            <a:off x="661475" y="522387"/>
+            <a:ext cx="10868745" cy="406995"/>
+          </a:xfrm>
+          <a:prstGeom prst="rect">
+            <a:avLst/>
+          </a:prstGeom>
+          <a:noFill/>
+          <a:ln/>
+        </p:spPr>
+        <p:txBody>
+          <a:bodyPr wrap="none" lIns="0" tIns="0" rIns="0" bIns="0" rtlCol="0" anchor="t"/>
+          <a:lstStyle/>
+          <a:p>
+            <a:pPr marL="0" indent="0" algn="l">
+              <a:lnSpc>
+                <a:spcPct val="104000"/>
+              </a:lnSpc>
+              <a:buNone/>
+            </a:pPr>
+            <a:r>
+              <a:rPr lang="en-US" sz="2550" b="1" dirty="0">
+                <a:solidFill>
+                  <a:srgbClr val="002F6B"/>
+                </a:solidFill>
+                <a:latin typeface="Inter Bold" pitchFamily="34" charset="0"/>
+                <a:ea typeface="Inter Bold" pitchFamily="34" charset="-122"/>
+                <a:cs typeface="Inter Bold" pitchFamily="34" charset="-120"/>
+              </a:rPr>
+              <a:t>Question</a:t>
+            </a:r>
+            <a:endParaRPr lang="en-US" sz="2550" dirty="0"/>
+          </a:p>
+        </p:txBody>
+      </p:sp>
+      <p:grpSp>
+        <p:nvGrpSpPr>
+          <p:cNvPr id="36" name="Group 35">
+            <a:extLst>
+              <a:ext uri="{FF2B5EF4-FFF2-40B4-BE49-F238E27FC236}">
+                <a16:creationId xmlns:a16="http://schemas.microsoft.com/office/drawing/2014/main" id="{6B8EE5C4-B6FF-830F-9C15-A5E4A97600FD}"/>
+              </a:ext>
+            </a:extLst>
+          </p:cNvPr>
+          <p:cNvGrpSpPr/>
+          <p:nvPr/>
+        </p:nvGrpSpPr>
+        <p:grpSpPr>
+          <a:xfrm>
+            <a:off x="661475" y="1117495"/>
+            <a:ext cx="6731363" cy="673587"/>
+            <a:chOff x="661475" y="1117495"/>
+            <a:chExt cx="6731363" cy="673587"/>
+          </a:xfrm>
+        </p:grpSpPr>
+        <p:sp>
+          <p:nvSpPr>
+            <p:cNvPr id="3" name="Text 1">
+              <a:extLst>
+                <a:ext uri="{FF2B5EF4-FFF2-40B4-BE49-F238E27FC236}">
+                  <a16:creationId xmlns:a16="http://schemas.microsoft.com/office/drawing/2014/main" id="{CFDC0A54-1A08-1018-358D-5D77A57F5A2A}"/>
+                </a:ext>
+              </a:extLst>
+            </p:cNvPr>
+            <p:cNvSpPr/>
+            <p:nvPr/>
+          </p:nvSpPr>
+          <p:spPr>
+            <a:xfrm>
+              <a:off x="661475" y="1117495"/>
+              <a:ext cx="5868721" cy="406996"/>
+            </a:xfrm>
+            <a:prstGeom prst="rect">
+              <a:avLst/>
+            </a:prstGeom>
+            <a:noFill/>
+            <a:ln/>
+          </p:spPr>
+          <p:txBody>
+            <a:bodyPr wrap="none" lIns="0" tIns="0" rIns="0" bIns="0" rtlCol="0" anchor="t"/>
+            <a:lstStyle/>
+            <a:p>
+              <a:pPr marL="285750" lvl="0" indent="-285750">
+                <a:buFont typeface="Arial" panose="020B0604020202020204" pitchFamily="34" charset="0"/>
+                <a:buChar char="•"/>
+              </a:pPr>
+              <a:r>
+                <a:rPr lang="en-US" dirty="0"/>
+                <a:t>What are inherently sequential tasks?</a:t>
+              </a:r>
+            </a:p>
+            <a:p>
+              <a:pPr>
+                <a:lnSpc>
+                  <a:spcPct val="113000"/>
+                </a:lnSpc>
+              </a:pPr>
+              <a:endParaRPr lang="en-US" sz="1000" dirty="0"/>
+            </a:p>
+          </p:txBody>
+        </p:sp>
+        <p:grpSp>
+          <p:nvGrpSpPr>
+            <p:cNvPr id="14" name="Group 13">
+              <a:extLst>
+                <a:ext uri="{FF2B5EF4-FFF2-40B4-BE49-F238E27FC236}">
+                  <a16:creationId xmlns:a16="http://schemas.microsoft.com/office/drawing/2014/main" id="{8B4F064F-FEA5-2918-5FEF-18A96D4AC137}"/>
+                </a:ext>
+              </a:extLst>
+            </p:cNvPr>
+            <p:cNvGrpSpPr/>
+            <p:nvPr/>
+          </p:nvGrpSpPr>
+          <p:grpSpPr>
+            <a:xfrm>
+              <a:off x="730487" y="1384086"/>
+              <a:ext cx="6662351" cy="406996"/>
+              <a:chOff x="6261043" y="2443460"/>
+              <a:chExt cx="5275527" cy="767655"/>
+            </a:xfrm>
+          </p:grpSpPr>
+          <p:pic>
+            <p:nvPicPr>
+              <p:cNvPr id="5" name="Image 1" descr="preencoded.png">
+                <a:extLst>
+                  <a:ext uri="{FF2B5EF4-FFF2-40B4-BE49-F238E27FC236}">
+                    <a16:creationId xmlns:a16="http://schemas.microsoft.com/office/drawing/2014/main" id="{0983F1BA-DE02-CD16-716F-F4CF0AA41F23}"/>
+                  </a:ext>
+                </a:extLst>
+              </p:cNvPr>
+              <p:cNvPicPr>
+                <a:picLocks noChangeAspect="1"/>
+              </p:cNvPicPr>
+              <p:nvPr/>
+            </p:nvPicPr>
+            <p:blipFill>
+              <a:blip>
+                <a:extLst>
+                  <a:ext uri="{96DAC541-7B7A-43D3-8B79-37D633B846F1}">
+                    <asvg:svgBlip xmlns:asvg="http://schemas.microsoft.com/office/drawing/2016/SVG/main" r:embed="rId3"/>
+                  </a:ext>
+                </a:extLst>
+              </a:blip>
+              <a:stretch>
+                <a:fillRect/>
+              </a:stretch>
+            </p:blipFill>
+            <p:spPr>
+              <a:xfrm>
+                <a:off x="6261043" y="2443460"/>
+                <a:ext cx="5275527" cy="767655"/>
+              </a:xfrm>
+              <a:prstGeom prst="rect">
+                <a:avLst/>
+              </a:prstGeom>
+            </p:spPr>
+          </p:pic>
+          <p:sp>
+            <p:nvSpPr>
+              <p:cNvPr id="6" name="Text 2">
+                <a:extLst>
+                  <a:ext uri="{FF2B5EF4-FFF2-40B4-BE49-F238E27FC236}">
+                    <a16:creationId xmlns:a16="http://schemas.microsoft.com/office/drawing/2014/main" id="{17727FDA-24E1-726C-BCFF-D31A09DEB3DA}"/>
+                  </a:ext>
+                </a:extLst>
+              </p:cNvPr>
+              <p:cNvSpPr/>
+              <p:nvPr/>
+            </p:nvSpPr>
+            <p:spPr>
+              <a:xfrm>
+                <a:off x="6486462" y="2592685"/>
+                <a:ext cx="4900887" cy="203498"/>
+              </a:xfrm>
+              <a:prstGeom prst="rect">
+                <a:avLst/>
+              </a:prstGeom>
+              <a:noFill/>
+              <a:ln/>
+            </p:spPr>
+            <p:txBody>
+              <a:bodyPr wrap="none" lIns="0" tIns="0" rIns="0" bIns="0" rtlCol="0" anchor="t"/>
+              <a:lstStyle/>
+              <a:p>
+                <a:pPr marL="0" indent="0" algn="l">
+                  <a:lnSpc>
+                    <a:spcPct val="104000"/>
+                  </a:lnSpc>
+                  <a:buNone/>
+                </a:pPr>
+                <a:r>
+                  <a:rPr lang="en-US" sz="1250" b="1" dirty="0">
+                    <a:solidFill>
+                      <a:srgbClr val="005A9B"/>
+                    </a:solidFill>
+                    <a:latin typeface="Inter Bold" pitchFamily="34" charset="0"/>
+                  </a:rPr>
+                  <a:t>Each step is reply on the previous step’s result.</a:t>
+                </a:r>
+                <a:endParaRPr lang="en-US" sz="1250" dirty="0"/>
+              </a:p>
+            </p:txBody>
+          </p:sp>
+        </p:grpSp>
+      </p:grpSp>
+      <p:sp>
+        <p:nvSpPr>
+          <p:cNvPr id="20" name="Text 1">
+            <a:extLst>
+              <a:ext uri="{FF2B5EF4-FFF2-40B4-BE49-F238E27FC236}">
+                <a16:creationId xmlns:a16="http://schemas.microsoft.com/office/drawing/2014/main" id="{DAFE047E-088E-B272-95EC-6CB3A7684B98}"/>
+              </a:ext>
+            </a:extLst>
+          </p:cNvPr>
+          <p:cNvSpPr/>
+          <p:nvPr/>
+        </p:nvSpPr>
+        <p:spPr>
+          <a:xfrm>
+            <a:off x="730487" y="5059654"/>
+            <a:ext cx="11478330" cy="227419"/>
+          </a:xfrm>
+          <a:prstGeom prst="rect">
+            <a:avLst/>
+          </a:prstGeom>
+          <a:noFill/>
+          <a:ln/>
+        </p:spPr>
+        <p:txBody>
+          <a:bodyPr wrap="none" lIns="0" tIns="0" rIns="0" bIns="0" rtlCol="0" anchor="t"/>
+          <a:lstStyle/>
+          <a:p>
+            <a:pPr algn="l">
+              <a:lnSpc>
+                <a:spcPct val="113000"/>
+              </a:lnSpc>
+            </a:pPr>
+            <a:endParaRPr lang="en-US" sz="1000" dirty="0"/>
+          </a:p>
+        </p:txBody>
+      </p:sp>
+      <p:grpSp>
+        <p:nvGrpSpPr>
+          <p:cNvPr id="37" name="Group 36">
+            <a:extLst>
+              <a:ext uri="{FF2B5EF4-FFF2-40B4-BE49-F238E27FC236}">
+                <a16:creationId xmlns:a16="http://schemas.microsoft.com/office/drawing/2014/main" id="{14CD904D-42FA-EB15-0AB2-29F15DA8AAD1}"/>
+              </a:ext>
+            </a:extLst>
+          </p:cNvPr>
+          <p:cNvGrpSpPr/>
+          <p:nvPr/>
+        </p:nvGrpSpPr>
+        <p:grpSpPr>
+          <a:xfrm>
+            <a:off x="661475" y="1847669"/>
+            <a:ext cx="11478330" cy="892522"/>
+            <a:chOff x="661475" y="1943482"/>
+            <a:chExt cx="11478330" cy="892522"/>
+          </a:xfrm>
+        </p:grpSpPr>
+        <p:sp>
+          <p:nvSpPr>
+            <p:cNvPr id="18" name="Text 1">
+              <a:extLst>
+                <a:ext uri="{FF2B5EF4-FFF2-40B4-BE49-F238E27FC236}">
+                  <a16:creationId xmlns:a16="http://schemas.microsoft.com/office/drawing/2014/main" id="{3A67BAED-4A3A-8305-CF7A-B273C1AA8926}"/>
+                </a:ext>
+              </a:extLst>
+            </p:cNvPr>
+            <p:cNvSpPr/>
+            <p:nvPr/>
+          </p:nvSpPr>
+          <p:spPr>
+            <a:xfrm>
+              <a:off x="661475" y="1943482"/>
+              <a:ext cx="11478330" cy="406997"/>
+            </a:xfrm>
+            <a:prstGeom prst="rect">
+              <a:avLst/>
+            </a:prstGeom>
+            <a:noFill/>
+            <a:ln/>
+          </p:spPr>
+          <p:txBody>
+            <a:bodyPr wrap="none" lIns="0" tIns="0" rIns="0" bIns="0" rtlCol="0" anchor="t"/>
+            <a:lstStyle/>
+            <a:p>
+              <a:pPr marL="285750" lvl="0" indent="-285750">
+                <a:buFont typeface="Arial" panose="020B0604020202020204" pitchFamily="34" charset="0"/>
+                <a:buChar char="•"/>
+              </a:pPr>
+              <a:r>
+                <a:rPr lang="en-US" dirty="0"/>
+                <a:t>What does I/O bound mean?</a:t>
+              </a:r>
+            </a:p>
+          </p:txBody>
+        </p:sp>
+        <p:grpSp>
+          <p:nvGrpSpPr>
+            <p:cNvPr id="27" name="Group 26">
+              <a:extLst>
+                <a:ext uri="{FF2B5EF4-FFF2-40B4-BE49-F238E27FC236}">
+                  <a16:creationId xmlns:a16="http://schemas.microsoft.com/office/drawing/2014/main" id="{2AF14D74-8AB4-45A9-9F05-FE529C4BE2B9}"/>
+                </a:ext>
+              </a:extLst>
+            </p:cNvPr>
+            <p:cNvGrpSpPr/>
+            <p:nvPr/>
+          </p:nvGrpSpPr>
+          <p:grpSpPr>
+            <a:xfrm>
+              <a:off x="730487" y="2257279"/>
+              <a:ext cx="11130834" cy="578725"/>
+              <a:chOff x="6261043" y="2443461"/>
+              <a:chExt cx="5275527" cy="513403"/>
+            </a:xfrm>
+          </p:grpSpPr>
+          <p:pic>
+            <p:nvPicPr>
+              <p:cNvPr id="28" name="Image 1" descr="preencoded.png">
+                <a:extLst>
+                  <a:ext uri="{FF2B5EF4-FFF2-40B4-BE49-F238E27FC236}">
+                    <a16:creationId xmlns:a16="http://schemas.microsoft.com/office/drawing/2014/main" id="{967568C8-797C-8FB6-C23E-017C95C03C2B}"/>
+                  </a:ext>
+                </a:extLst>
+              </p:cNvPr>
+              <p:cNvPicPr>
+                <a:picLocks noChangeAspect="1"/>
+              </p:cNvPicPr>
+              <p:nvPr/>
+            </p:nvPicPr>
+            <p:blipFill>
+              <a:blip>
+                <a:extLst>
+                  <a:ext uri="{96DAC541-7B7A-43D3-8B79-37D633B846F1}">
+                    <asvg:svgBlip xmlns:asvg="http://schemas.microsoft.com/office/drawing/2016/SVG/main" r:embed="rId3"/>
+                  </a:ext>
+                </a:extLst>
+              </a:blip>
+              <a:stretch>
+                <a:fillRect/>
+              </a:stretch>
+            </p:blipFill>
+            <p:spPr>
+              <a:xfrm>
+                <a:off x="6261043" y="2443461"/>
+                <a:ext cx="5275527" cy="513403"/>
+              </a:xfrm>
+              <a:prstGeom prst="rect">
+                <a:avLst/>
+              </a:prstGeom>
+            </p:spPr>
+          </p:pic>
+          <p:sp>
+            <p:nvSpPr>
+              <p:cNvPr id="29" name="Text 2">
+                <a:extLst>
+                  <a:ext uri="{FF2B5EF4-FFF2-40B4-BE49-F238E27FC236}">
+                    <a16:creationId xmlns:a16="http://schemas.microsoft.com/office/drawing/2014/main" id="{62ADBE18-FB21-0206-8F51-793AB1A61E14}"/>
+                  </a:ext>
+                </a:extLst>
+              </p:cNvPr>
+              <p:cNvSpPr/>
+              <p:nvPr/>
+            </p:nvSpPr>
+            <p:spPr>
+              <a:xfrm>
+                <a:off x="6486462" y="2592685"/>
+                <a:ext cx="4900887" cy="203498"/>
+              </a:xfrm>
+              <a:prstGeom prst="rect">
+                <a:avLst/>
+              </a:prstGeom>
+              <a:noFill/>
+              <a:ln/>
+            </p:spPr>
+            <p:txBody>
+              <a:bodyPr wrap="none" lIns="0" tIns="0" rIns="0" bIns="0" rtlCol="0" anchor="t"/>
+              <a:lstStyle/>
+              <a:p>
+                <a:pPr>
+                  <a:lnSpc>
+                    <a:spcPct val="104000"/>
+                  </a:lnSpc>
+                </a:pPr>
+                <a:r>
+                  <a:rPr lang="zh-CN" altLang="en-US" sz="1250" b="1" dirty="0">
+                    <a:solidFill>
+                      <a:srgbClr val="005A9B"/>
+                    </a:solidFill>
+                    <a:latin typeface="Inter Bold" pitchFamily="34" charset="0"/>
+                  </a:rPr>
+                  <a:t>程序的性能瓶颈在于等待数据从外部设备（磁盘</a:t>
+                </a:r>
+                <a:r>
+                  <a:rPr lang="en-US" altLang="zh-CN" sz="1250" b="1" dirty="0">
+                    <a:solidFill>
+                      <a:srgbClr val="005A9B"/>
+                    </a:solidFill>
+                    <a:latin typeface="Inter Bold" pitchFamily="34" charset="0"/>
+                  </a:rPr>
+                  <a:t>/</a:t>
+                </a:r>
+                <a:r>
+                  <a:rPr lang="zh-CN" altLang="en-US" sz="1250" b="1" dirty="0">
+                    <a:solidFill>
+                      <a:srgbClr val="005A9B"/>
+                    </a:solidFill>
+                    <a:latin typeface="Inter Bold" pitchFamily="34" charset="0"/>
+                  </a:rPr>
+                  <a:t>网卡）传入或传出，而非 </a:t>
+                </a:r>
+                <a:r>
+                  <a:rPr lang="en-US" altLang="zh-CN" sz="1250" b="1" dirty="0">
+                    <a:solidFill>
+                      <a:srgbClr val="005A9B"/>
+                    </a:solidFill>
+                    <a:latin typeface="Inter Bold" pitchFamily="34" charset="0"/>
+                  </a:rPr>
+                  <a:t>CPU </a:t>
+                </a:r>
+                <a:r>
+                  <a:rPr lang="zh-CN" altLang="en-US" sz="1250" b="1" dirty="0">
+                    <a:solidFill>
+                      <a:srgbClr val="005A9B"/>
+                    </a:solidFill>
+                    <a:latin typeface="Inter Bold" pitchFamily="34" charset="0"/>
+                  </a:rPr>
+                  <a:t>内部计算</a:t>
+                </a:r>
+                <a:r>
+                  <a:rPr lang="en-US" altLang="zh-CN" sz="1250" b="1" dirty="0">
+                    <a:solidFill>
+                      <a:srgbClr val="005A9B"/>
+                    </a:solidFill>
+                    <a:latin typeface="Inter Bold" pitchFamily="34" charset="0"/>
+                  </a:rPr>
+                  <a:t>.</a:t>
+                </a:r>
+                <a:r>
+                  <a:rPr lang="zh-CN" altLang="en-US" sz="1250" b="1" dirty="0">
+                    <a:solidFill>
+                      <a:srgbClr val="005A9B"/>
+                    </a:solidFill>
+                    <a:latin typeface="Inter Bold" pitchFamily="34" charset="0"/>
+                  </a:rPr>
+                  <a:t>典型的解决方案：异步非阻塞 </a:t>
+                </a:r>
+                <a:r>
+                  <a:rPr lang="en-US" altLang="zh-CN" sz="1250" b="1" dirty="0">
+                    <a:solidFill>
+                      <a:srgbClr val="005A9B"/>
+                    </a:solidFill>
+                    <a:latin typeface="Inter Bold" pitchFamily="34" charset="0"/>
+                  </a:rPr>
+                  <a:t>+ </a:t>
+                </a:r>
+                <a:r>
+                  <a:rPr lang="zh-CN" altLang="en-US" sz="1250" b="1" dirty="0">
+                    <a:solidFill>
+                      <a:srgbClr val="005A9B"/>
+                    </a:solidFill>
+                    <a:latin typeface="Inter Bold" pitchFamily="34" charset="0"/>
+                  </a:rPr>
+                  <a:t>批量操作 </a:t>
+                </a:r>
+                <a:r>
+                  <a:rPr lang="en-US" altLang="zh-CN" sz="1250" b="1" dirty="0">
+                    <a:solidFill>
+                      <a:srgbClr val="005A9B"/>
+                    </a:solidFill>
+                    <a:latin typeface="Inter Bold" pitchFamily="34" charset="0"/>
+                  </a:rPr>
+                  <a:t>+ </a:t>
+                </a:r>
+              </a:p>
+              <a:p>
+                <a:pPr>
+                  <a:lnSpc>
+                    <a:spcPct val="104000"/>
+                  </a:lnSpc>
+                </a:pPr>
+                <a:r>
+                  <a:rPr lang="zh-CN" altLang="en-US" sz="1250" b="1" dirty="0">
+                    <a:solidFill>
+                      <a:srgbClr val="005A9B"/>
+                    </a:solidFill>
+                    <a:latin typeface="Inter Bold" pitchFamily="34" charset="0"/>
+                  </a:rPr>
+                  <a:t>缓存（</a:t>
+                </a:r>
+                <a:r>
+                  <a:rPr lang="en-US" altLang="zh-CN" sz="1250" b="1" dirty="0">
+                    <a:solidFill>
+                      <a:srgbClr val="005A9B"/>
+                    </a:solidFill>
+                    <a:latin typeface="Inter Bold" pitchFamily="34" charset="0"/>
+                  </a:rPr>
+                  <a:t>Redis/</a:t>
+                </a:r>
+                <a:r>
+                  <a:rPr lang="zh-CN" altLang="en-US" sz="1250" b="1" dirty="0">
+                    <a:solidFill>
+                      <a:srgbClr val="005A9B"/>
+                    </a:solidFill>
+                    <a:latin typeface="Inter Bold" pitchFamily="34" charset="0"/>
+                  </a:rPr>
+                  <a:t>内存）</a:t>
+                </a:r>
+                <a:r>
+                  <a:rPr lang="en-US" sz="1250" b="1" dirty="0">
+                    <a:solidFill>
+                      <a:srgbClr val="005A9B"/>
+                    </a:solidFill>
+                    <a:latin typeface="Inter Bold" pitchFamily="34" charset="0"/>
+                  </a:rPr>
+                  <a:t> </a:t>
+                </a:r>
+                <a:endParaRPr lang="en-US" sz="1250" dirty="0"/>
+              </a:p>
+            </p:txBody>
+          </p:sp>
+        </p:grpSp>
+      </p:grpSp>
+      <p:grpSp>
+        <p:nvGrpSpPr>
+          <p:cNvPr id="38" name="Group 37">
+            <a:extLst>
+              <a:ext uri="{FF2B5EF4-FFF2-40B4-BE49-F238E27FC236}">
+                <a16:creationId xmlns:a16="http://schemas.microsoft.com/office/drawing/2014/main" id="{173CF875-1FBD-E0A6-9657-7B9EE2F061DB}"/>
+              </a:ext>
+            </a:extLst>
+          </p:cNvPr>
+          <p:cNvGrpSpPr/>
+          <p:nvPr/>
+        </p:nvGrpSpPr>
+        <p:grpSpPr>
+          <a:xfrm>
+            <a:off x="661475" y="2809495"/>
+            <a:ext cx="11504208" cy="726915"/>
+            <a:chOff x="787997" y="3210429"/>
+            <a:chExt cx="11504208" cy="726915"/>
+          </a:xfrm>
+        </p:grpSpPr>
+        <p:sp>
+          <p:nvSpPr>
+            <p:cNvPr id="22" name="Text 1">
+              <a:extLst>
+                <a:ext uri="{FF2B5EF4-FFF2-40B4-BE49-F238E27FC236}">
+                  <a16:creationId xmlns:a16="http://schemas.microsoft.com/office/drawing/2014/main" id="{EEC21932-6681-A0A3-60A4-E47146B73E4F}"/>
+                </a:ext>
+              </a:extLst>
+            </p:cNvPr>
+            <p:cNvSpPr/>
+            <p:nvPr/>
+          </p:nvSpPr>
+          <p:spPr>
+            <a:xfrm>
+              <a:off x="813875" y="3210429"/>
+              <a:ext cx="11478330" cy="351853"/>
+            </a:xfrm>
+            <a:prstGeom prst="rect">
+              <a:avLst/>
+            </a:prstGeom>
+            <a:noFill/>
+            <a:ln/>
+          </p:spPr>
+          <p:txBody>
+            <a:bodyPr wrap="none" lIns="0" tIns="0" rIns="0" bIns="0" rtlCol="0" anchor="t"/>
+            <a:lstStyle/>
+            <a:p>
+              <a:pPr marL="285750" lvl="0" indent="-285750">
+                <a:buFont typeface="Arial" panose="020B0604020202020204" pitchFamily="34" charset="0"/>
+                <a:buChar char="•"/>
+              </a:pPr>
+              <a:r>
+                <a:rPr lang="en-US" dirty="0"/>
+                <a:t>How is concurrent processing currently being used in the real world?</a:t>
+              </a:r>
+            </a:p>
+          </p:txBody>
+        </p:sp>
+        <p:grpSp>
+          <p:nvGrpSpPr>
+            <p:cNvPr id="30" name="Group 29">
+              <a:extLst>
+                <a:ext uri="{FF2B5EF4-FFF2-40B4-BE49-F238E27FC236}">
+                  <a16:creationId xmlns:a16="http://schemas.microsoft.com/office/drawing/2014/main" id="{9845EAC3-5B54-B0BB-7548-B3F339E8C2FD}"/>
+                </a:ext>
+              </a:extLst>
+            </p:cNvPr>
+            <p:cNvGrpSpPr/>
+            <p:nvPr/>
+          </p:nvGrpSpPr>
+          <p:grpSpPr>
+            <a:xfrm>
+              <a:off x="787997" y="3539742"/>
+              <a:ext cx="11130834" cy="397602"/>
+              <a:chOff x="6261043" y="2443460"/>
+              <a:chExt cx="5275527" cy="767655"/>
+            </a:xfrm>
+          </p:grpSpPr>
+          <p:pic>
+            <p:nvPicPr>
+              <p:cNvPr id="31" name="Image 1" descr="preencoded.png">
+                <a:extLst>
+                  <a:ext uri="{FF2B5EF4-FFF2-40B4-BE49-F238E27FC236}">
+                    <a16:creationId xmlns:a16="http://schemas.microsoft.com/office/drawing/2014/main" id="{A117B723-F2CD-3E44-E7C2-80D1CF968CC5}"/>
+                  </a:ext>
+                </a:extLst>
+              </p:cNvPr>
+              <p:cNvPicPr>
+                <a:picLocks noChangeAspect="1"/>
+              </p:cNvPicPr>
+              <p:nvPr/>
+            </p:nvPicPr>
+            <p:blipFill>
+              <a:blip>
+                <a:extLst>
+                  <a:ext uri="{96DAC541-7B7A-43D3-8B79-37D633B846F1}">
+                    <asvg:svgBlip xmlns:asvg="http://schemas.microsoft.com/office/drawing/2016/SVG/main" r:embed="rId3"/>
+                  </a:ext>
+                </a:extLst>
+              </a:blip>
+              <a:stretch>
+                <a:fillRect/>
+              </a:stretch>
+            </p:blipFill>
+            <p:spPr>
+              <a:xfrm>
+                <a:off x="6261043" y="2443460"/>
+                <a:ext cx="5275527" cy="767655"/>
+              </a:xfrm>
+              <a:prstGeom prst="rect">
+                <a:avLst/>
+              </a:prstGeom>
+            </p:spPr>
+          </p:pic>
+          <p:sp>
+            <p:nvSpPr>
+              <p:cNvPr id="32" name="Text 2">
+                <a:extLst>
+                  <a:ext uri="{FF2B5EF4-FFF2-40B4-BE49-F238E27FC236}">
+                    <a16:creationId xmlns:a16="http://schemas.microsoft.com/office/drawing/2014/main" id="{7CBD7958-5B23-1351-A411-593719060B74}"/>
+                  </a:ext>
+                </a:extLst>
+              </p:cNvPr>
+              <p:cNvSpPr/>
+              <p:nvPr/>
+            </p:nvSpPr>
+            <p:spPr>
+              <a:xfrm>
+                <a:off x="6486462" y="2592685"/>
+                <a:ext cx="4900887" cy="203498"/>
+              </a:xfrm>
+              <a:prstGeom prst="rect">
+                <a:avLst/>
+              </a:prstGeom>
+              <a:noFill/>
+              <a:ln/>
+            </p:spPr>
+            <p:txBody>
+              <a:bodyPr wrap="none" lIns="0" tIns="0" rIns="0" bIns="0" rtlCol="0" anchor="t"/>
+              <a:lstStyle/>
+              <a:p>
+                <a:pPr>
+                  <a:lnSpc>
+                    <a:spcPct val="104000"/>
+                  </a:lnSpc>
+                </a:pPr>
+                <a:endParaRPr lang="en-US" sz="1250" dirty="0"/>
+              </a:p>
+            </p:txBody>
+          </p:sp>
+        </p:grpSp>
+      </p:grpSp>
+      <p:sp>
+        <p:nvSpPr>
+          <p:cNvPr id="7" name="Text 2">
+            <a:extLst>
+              <a:ext uri="{FF2B5EF4-FFF2-40B4-BE49-F238E27FC236}">
+                <a16:creationId xmlns:a16="http://schemas.microsoft.com/office/drawing/2014/main" id="{DB6DC9D7-0BAF-9B21-777A-0FF5084B345C}"/>
+              </a:ext>
+            </a:extLst>
+          </p:cNvPr>
+          <p:cNvSpPr/>
+          <p:nvPr/>
+        </p:nvSpPr>
+        <p:spPr>
+          <a:xfrm>
+            <a:off x="918550" y="3206692"/>
+            <a:ext cx="10340381" cy="229390"/>
+          </a:xfrm>
+          <a:prstGeom prst="rect">
+            <a:avLst/>
+          </a:prstGeom>
+          <a:noFill/>
+          <a:ln/>
+        </p:spPr>
+        <p:txBody>
+          <a:bodyPr wrap="none" lIns="0" tIns="0" rIns="0" bIns="0" rtlCol="0" anchor="t"/>
+          <a:lstStyle/>
+          <a:p>
+            <a:pPr>
+              <a:lnSpc>
+                <a:spcPct val="104000"/>
+              </a:lnSpc>
+            </a:pPr>
+            <a:r>
+              <a:rPr lang="en-US" sz="1250" b="1" dirty="0">
+                <a:solidFill>
+                  <a:srgbClr val="005A9B"/>
+                </a:solidFill>
+                <a:latin typeface="Inter Bold" pitchFamily="34" charset="0"/>
+              </a:rPr>
+              <a:t>Heavily calculation area, like AI, 3D rendering; web rendering.</a:t>
+            </a:r>
+            <a:endParaRPr lang="en-US" sz="1250" dirty="0"/>
+          </a:p>
+        </p:txBody>
+      </p:sp>
+    </p:spTree>
+    <p:extLst>
+      <p:ext uri="{BB962C8B-B14F-4D97-AF65-F5344CB8AC3E}">
+        <p14:creationId xmlns:p14="http://schemas.microsoft.com/office/powerpoint/2010/main" val="2757054430"/>
+      </p:ext>
+    </p:extLst>
+  </p:cSld>
+  <p:clrMapOvr>
+    <a:masterClrMapping/>
+  </p:clrMapOvr>
+</p:sld>
+</file>
+
+<file path=ppt/slides/slide6.xml><?xml version="1.0" encoding="utf-8"?>
+<p:sld xmlns:a="http://schemas.openxmlformats.org/drawingml/2006/main" xmlns:r="http://schemas.openxmlformats.org/officeDocument/2006/relationships" xmlns:p="http://schemas.openxmlformats.org/presentationml/2006/main">
+  <p:cSld>
+    <p:spTree>
+      <p:nvGrpSpPr>
+        <p:cNvPr id="1" name="">
+          <a:extLst>
+            <a:ext uri="{FF2B5EF4-FFF2-40B4-BE49-F238E27FC236}">
+              <a16:creationId xmlns:a16="http://schemas.microsoft.com/office/drawing/2014/main" id="{D6097ED3-C2D1-EE88-7718-E27705B10592}"/>
+            </a:ext>
+          </a:extLst>
+        </p:cNvPr>
+        <p:cNvGrpSpPr/>
+        <p:nvPr/>
+      </p:nvGrpSpPr>
+      <p:grpSpPr>
+        <a:xfrm>
+          <a:off x="0" y="0"/>
+          <a:ext cx="0" cy="0"/>
+          <a:chOff x="0" y="0"/>
+          <a:chExt cx="0" cy="0"/>
+        </a:xfrm>
+      </p:grpSpPr>
+      <p:sp>
+        <p:nvSpPr>
+          <p:cNvPr id="2" name="Text 0">
+            <a:extLst>
+              <a:ext uri="{FF2B5EF4-FFF2-40B4-BE49-F238E27FC236}">
+                <a16:creationId xmlns:a16="http://schemas.microsoft.com/office/drawing/2014/main" id="{A8C01354-D498-3454-3AF1-8860C1A97623}"/>
+              </a:ext>
+            </a:extLst>
+          </p:cNvPr>
+          <p:cNvSpPr/>
+          <p:nvPr/>
+        </p:nvSpPr>
+        <p:spPr>
+          <a:xfrm>
+            <a:off x="376804" y="2465206"/>
+            <a:ext cx="10868745" cy="1235526"/>
+          </a:xfrm>
+          <a:prstGeom prst="rect">
+            <a:avLst/>
+          </a:prstGeom>
+          <a:noFill/>
+          <a:ln/>
+        </p:spPr>
+        <p:txBody>
+          <a:bodyPr wrap="square" lIns="0" tIns="0" rIns="0" bIns="0" rtlCol="0" anchor="t">
+            <a:normAutofit/>
+          </a:bodyPr>
+          <a:lstStyle/>
+          <a:p>
+            <a:pPr marL="0" marR="0" lvl="0" indent="0" algn="ctr" defTabSz="914400" rtl="0" eaLnBrk="1" fontAlgn="auto" latinLnBrk="0" hangingPunct="1">
+              <a:lnSpc>
+                <a:spcPct val="104000"/>
+              </a:lnSpc>
+              <a:spcBef>
+                <a:spcPts val="0"/>
+              </a:spcBef>
+              <a:spcAft>
+                <a:spcPts val="0"/>
+              </a:spcAft>
+              <a:buClrTx/>
+              <a:buSzTx/>
+              <a:buFontTx/>
+              <a:buNone/>
+              <a:tabLst/>
+              <a:defRPr/>
+            </a:pPr>
+            <a:r>
+              <a:rPr kumimoji="0" lang="en-US" sz="7400" b="1" i="0" u="none" strike="noStrike" kern="1200" cap="none" spc="0" normalizeH="0" baseline="0" noProof="0" dirty="0">
+                <a:ln>
+                  <a:noFill/>
+                </a:ln>
+                <a:solidFill>
+                  <a:srgbClr val="002F6B"/>
+                </a:solidFill>
+                <a:effectLst/>
+                <a:uLnTx/>
+                <a:uFillTx/>
+                <a:latin typeface="Inter Bold" pitchFamily="34" charset="0"/>
+                <a:ea typeface="Inter Bold" pitchFamily="34" charset="-122"/>
+                <a:cs typeface="Inter Bold" pitchFamily="34" charset="-120"/>
+              </a:rPr>
+              <a:t>Chapter 02</a:t>
+            </a:r>
+            <a:endParaRPr kumimoji="0" lang="en-US" sz="7400" b="0" i="0" u="none" strike="noStrike" kern="1200" cap="none" spc="0" normalizeH="0" baseline="0" noProof="0" dirty="0">
+              <a:ln>
+                <a:noFill/>
+              </a:ln>
+              <a:solidFill>
+                <a:prstClr val="black"/>
+              </a:solidFill>
+              <a:effectLst/>
+              <a:uLnTx/>
+              <a:uFillTx/>
+              <a:latin typeface="Calibri" panose="020F0502020204030204"/>
+              <a:ea typeface="+mn-ea"/>
+              <a:cs typeface="+mn-cs"/>
+            </a:endParaRPr>
+          </a:p>
+        </p:txBody>
+      </p:sp>
+    </p:spTree>
+    <p:extLst>
+      <p:ext uri="{BB962C8B-B14F-4D97-AF65-F5344CB8AC3E}">
+        <p14:creationId xmlns:p14="http://schemas.microsoft.com/office/powerpoint/2010/main" val="1902525021"/>
+      </p:ext>
+    </p:extLst>
+  </p:cSld>
+  <p:clrMapOvr>
+    <a:masterClrMapping/>
+  </p:clrMapOvr>
+</p:sld>
+</file>
+
+<file path=ppt/slides/slide7.xml><?xml version="1.0" encoding="utf-8"?>
+<p:sld xmlns:a="http://schemas.openxmlformats.org/drawingml/2006/main" xmlns:r="http://schemas.openxmlformats.org/officeDocument/2006/relationships" xmlns:p="http://schemas.openxmlformats.org/presentationml/2006/main">
+  <p:cSld>
+    <p:spTree>
+      <p:nvGrpSpPr>
+        <p:cNvPr id="1" name="">
+          <a:extLst>
+            <a:ext uri="{FF2B5EF4-FFF2-40B4-BE49-F238E27FC236}">
+              <a16:creationId xmlns:a16="http://schemas.microsoft.com/office/drawing/2014/main" id="{CEF9FE73-8E8A-8942-BB48-FD219AA7632F}"/>
+            </a:ext>
+          </a:extLst>
+        </p:cNvPr>
+        <p:cNvGrpSpPr/>
+        <p:nvPr/>
+      </p:nvGrpSpPr>
+      <p:grpSpPr>
+        <a:xfrm>
+          <a:off x="0" y="0"/>
+          <a:ext cx="0" cy="0"/>
+          <a:chOff x="0" y="0"/>
+          <a:chExt cx="0" cy="0"/>
+        </a:xfrm>
+      </p:grpSpPr>
+      <p:sp>
+        <p:nvSpPr>
+          <p:cNvPr id="2" name="Text 0">
+            <a:extLst>
+              <a:ext uri="{FF2B5EF4-FFF2-40B4-BE49-F238E27FC236}">
+                <a16:creationId xmlns:a16="http://schemas.microsoft.com/office/drawing/2014/main" id="{A2D860E8-1045-5E80-D7AC-F796D31FBDAC}"/>
+              </a:ext>
+            </a:extLst>
+          </p:cNvPr>
+          <p:cNvSpPr/>
+          <p:nvPr/>
+        </p:nvSpPr>
+        <p:spPr>
+          <a:xfrm>
+            <a:off x="661475" y="522387"/>
+            <a:ext cx="10868745" cy="406995"/>
+          </a:xfrm>
+          <a:prstGeom prst="rect">
+            <a:avLst/>
+          </a:prstGeom>
+          <a:noFill/>
+          <a:ln/>
+        </p:spPr>
+        <p:txBody>
+          <a:bodyPr wrap="none" lIns="0" tIns="0" rIns="0" bIns="0" rtlCol="0" anchor="t"/>
+          <a:lstStyle/>
+          <a:p>
+            <a:pPr marL="0" indent="0" algn="l">
+              <a:lnSpc>
+                <a:spcPct val="104000"/>
+              </a:lnSpc>
+              <a:buNone/>
+            </a:pPr>
+            <a:r>
+              <a:rPr lang="en-US" sz="2550" b="1" dirty="0">
+                <a:solidFill>
+                  <a:srgbClr val="002F6B"/>
+                </a:solidFill>
+                <a:latin typeface="Inter Bold" pitchFamily="34" charset="0"/>
+                <a:ea typeface="Inter Bold" pitchFamily="34" charset="-122"/>
+                <a:cs typeface="Inter Bold" pitchFamily="34" charset="-120"/>
+              </a:rPr>
+              <a:t>Concurrent vs. Sequential vs. Parallel</a:t>
+            </a:r>
+            <a:endParaRPr lang="en-US" sz="2550" dirty="0"/>
+          </a:p>
+        </p:txBody>
+      </p:sp>
+      <p:sp>
+        <p:nvSpPr>
+          <p:cNvPr id="3" name="Text 1">
+            <a:extLst>
+              <a:ext uri="{FF2B5EF4-FFF2-40B4-BE49-F238E27FC236}">
+                <a16:creationId xmlns:a16="http://schemas.microsoft.com/office/drawing/2014/main" id="{9DF9995B-8236-77B3-5ECE-7361FEEA6B1A}"/>
+              </a:ext>
+            </a:extLst>
+          </p:cNvPr>
+          <p:cNvSpPr/>
+          <p:nvPr/>
+        </p:nvSpPr>
+        <p:spPr>
+          <a:xfrm>
+            <a:off x="661475" y="1108869"/>
+            <a:ext cx="11478330" cy="176014"/>
+          </a:xfrm>
+          <a:prstGeom prst="rect">
+            <a:avLst/>
+          </a:prstGeom>
+          <a:noFill/>
+          <a:ln/>
+        </p:spPr>
+        <p:txBody>
+          <a:bodyPr wrap="none" lIns="0" tIns="0" rIns="0" bIns="0" rtlCol="0" anchor="t"/>
+          <a:lstStyle/>
+          <a:p>
+            <a:pPr marL="0" indent="0" algn="l">
+              <a:lnSpc>
+                <a:spcPct val="113000"/>
+              </a:lnSpc>
+              <a:buNone/>
+            </a:pPr>
+            <a:r>
+              <a:rPr lang="en-US" sz="1000" dirty="0">
+                <a:solidFill>
+                  <a:srgbClr val="000000"/>
+                </a:solidFill>
+                <a:latin typeface="Inter" pitchFamily="34" charset="0"/>
+                <a:ea typeface="Inter" pitchFamily="34" charset="-122"/>
+                <a:cs typeface="Inter" pitchFamily="34" charset="-120"/>
+              </a:rPr>
+              <a:t>Three distinct models for executing tasks — each with different trade-offs in performance, complexity, and resource usage.</a:t>
+            </a:r>
+            <a:endParaRPr lang="en-US" sz="1000" dirty="0"/>
+          </a:p>
+        </p:txBody>
+      </p:sp>
+      <p:pic>
+        <p:nvPicPr>
+          <p:cNvPr id="4" name="Image 0" descr="preencoded.png">
+            <a:extLst>
+              <a:ext uri="{FF2B5EF4-FFF2-40B4-BE49-F238E27FC236}">
+                <a16:creationId xmlns:a16="http://schemas.microsoft.com/office/drawing/2014/main" id="{07E8DFA9-382B-6EB1-B21F-C5535BC7EB46}"/>
+              </a:ext>
+            </a:extLst>
+          </p:cNvPr>
+          <p:cNvPicPr>
+            <a:picLocks noChangeAspect="1"/>
+          </p:cNvPicPr>
+          <p:nvPr/>
+        </p:nvPicPr>
+        <p:blipFill>
+          <a:blip r:embed="rId3"/>
+          <a:stretch>
+            <a:fillRect/>
+          </a:stretch>
+        </p:blipFill>
+        <p:spPr>
+          <a:xfrm>
+            <a:off x="661475" y="1486694"/>
+            <a:ext cx="4747895" cy="4748014"/>
+          </a:xfrm>
+          <a:prstGeom prst="rect">
+            <a:avLst/>
+          </a:prstGeom>
+        </p:spPr>
+      </p:pic>
+      <p:pic>
+        <p:nvPicPr>
+          <p:cNvPr id="5" name="Image 1" descr="preencoded.png">
+            <a:extLst>
+              <a:ext uri="{FF2B5EF4-FFF2-40B4-BE49-F238E27FC236}">
+                <a16:creationId xmlns:a16="http://schemas.microsoft.com/office/drawing/2014/main" id="{79627ECA-292C-5CDA-D185-50557AE7EC9C}"/>
+              </a:ext>
+            </a:extLst>
+          </p:cNvPr>
+          <p:cNvPicPr>
+            <a:picLocks noChangeAspect="1"/>
+          </p:cNvPicPr>
+          <p:nvPr/>
+        </p:nvPicPr>
+        <p:blipFill>
+          <a:blip>
+            <a:extLst>
+              <a:ext uri="{96DAC541-7B7A-43D3-8B79-37D633B846F1}">
+                <asvg:svgBlip xmlns:asvg="http://schemas.microsoft.com/office/drawing/2016/SVG/main" r:embed="rId4"/>
+              </a:ext>
+            </a:extLst>
+          </a:blip>
+          <a:stretch>
+            <a:fillRect/>
+          </a:stretch>
+        </p:blipFill>
+        <p:spPr>
+          <a:xfrm>
+            <a:off x="6261043" y="2443460"/>
+            <a:ext cx="5275527" cy="767655"/>
+          </a:xfrm>
+          <a:prstGeom prst="rect">
+            <a:avLst/>
+          </a:prstGeom>
+        </p:spPr>
+      </p:pic>
+      <p:sp>
+        <p:nvSpPr>
+          <p:cNvPr id="6" name="Text 2">
+            <a:extLst>
+              <a:ext uri="{FF2B5EF4-FFF2-40B4-BE49-F238E27FC236}">
+                <a16:creationId xmlns:a16="http://schemas.microsoft.com/office/drawing/2014/main" id="{E6AC5787-7DAB-65C6-9FBA-91BBB163FD66}"/>
+              </a:ext>
+            </a:extLst>
+          </p:cNvPr>
+          <p:cNvSpPr/>
+          <p:nvPr/>
+        </p:nvSpPr>
+        <p:spPr>
+          <a:xfrm>
+            <a:off x="6486462" y="2592685"/>
+            <a:ext cx="4900887" cy="203498"/>
+          </a:xfrm>
+          <a:prstGeom prst="rect">
+            <a:avLst/>
+          </a:prstGeom>
+          <a:noFill/>
+          <a:ln/>
+        </p:spPr>
+        <p:txBody>
+          <a:bodyPr wrap="none" lIns="0" tIns="0" rIns="0" bIns="0" rtlCol="0" anchor="t"/>
+          <a:lstStyle/>
+          <a:p>
+            <a:pPr marL="0" indent="0" algn="l">
+              <a:lnSpc>
+                <a:spcPct val="104000"/>
+              </a:lnSpc>
+              <a:buNone/>
+            </a:pPr>
+            <a:r>
+              <a:rPr lang="en-US" sz="1250" b="1" dirty="0">
+                <a:solidFill>
+                  <a:srgbClr val="005A9B"/>
+                </a:solidFill>
+                <a:latin typeface="Inter Bold" pitchFamily="34" charset="0"/>
+                <a:ea typeface="Inter Bold" pitchFamily="34" charset="-122"/>
+                <a:cs typeface="Inter Bold" pitchFamily="34" charset="-120"/>
+              </a:rPr>
+              <a:t>Sequential</a:t>
+            </a:r>
+            <a:endParaRPr lang="en-US" sz="1250" dirty="0"/>
+          </a:p>
+        </p:txBody>
+      </p:sp>
+      <p:sp>
+        <p:nvSpPr>
+          <p:cNvPr id="7" name="Text 3">
+            <a:extLst>
+              <a:ext uri="{FF2B5EF4-FFF2-40B4-BE49-F238E27FC236}">
+                <a16:creationId xmlns:a16="http://schemas.microsoft.com/office/drawing/2014/main" id="{740A8F3B-8473-FA04-3C39-BA7D4DB8F973}"/>
+              </a:ext>
+            </a:extLst>
+          </p:cNvPr>
+          <p:cNvSpPr/>
+          <p:nvPr/>
+        </p:nvSpPr>
+        <p:spPr>
+          <a:xfrm>
+            <a:off x="6486462" y="2885877"/>
+            <a:ext cx="4900887" cy="176014"/>
+          </a:xfrm>
+          <a:prstGeom prst="rect">
+            <a:avLst/>
+          </a:prstGeom>
+          <a:noFill/>
+          <a:ln/>
+        </p:spPr>
+        <p:txBody>
+          <a:bodyPr wrap="none" lIns="0" tIns="0" rIns="0" bIns="0" rtlCol="0" anchor="t"/>
+          <a:lstStyle/>
+          <a:p>
+            <a:pPr marL="0" indent="0" algn="l">
+              <a:lnSpc>
+                <a:spcPct val="113000"/>
+              </a:lnSpc>
+              <a:buNone/>
+            </a:pPr>
+            <a:r>
+              <a:rPr lang="en-US" sz="1000" dirty="0">
+                <a:solidFill>
+                  <a:srgbClr val="000000"/>
+                </a:solidFill>
+                <a:latin typeface="Inter" pitchFamily="34" charset="0"/>
+                <a:ea typeface="Inter" pitchFamily="34" charset="-122"/>
+                <a:cs typeface="Inter" pitchFamily="34" charset="-120"/>
+              </a:rPr>
+              <a:t>Tasks run one after another. Simplest model, but idle during I/O waits.</a:t>
+            </a:r>
+            <a:endParaRPr lang="en-US" sz="1000" dirty="0"/>
+          </a:p>
+        </p:txBody>
+      </p:sp>
+      <p:pic>
+        <p:nvPicPr>
+          <p:cNvPr id="8" name="Image 2" descr="preencoded.png">
+            <a:extLst>
+              <a:ext uri="{FF2B5EF4-FFF2-40B4-BE49-F238E27FC236}">
+                <a16:creationId xmlns:a16="http://schemas.microsoft.com/office/drawing/2014/main" id="{CA0073FF-2F76-FF5B-B169-2D5B74875C18}"/>
+              </a:ext>
+            </a:extLst>
+          </p:cNvPr>
+          <p:cNvPicPr>
+            <a:picLocks noChangeAspect="1"/>
+          </p:cNvPicPr>
+          <p:nvPr/>
+        </p:nvPicPr>
+        <p:blipFill>
+          <a:blip>
+            <a:extLst>
+              <a:ext uri="{96DAC541-7B7A-43D3-8B79-37D633B846F1}">
+                <asvg:svgBlip xmlns:asvg="http://schemas.microsoft.com/office/drawing/2016/SVG/main" r:embed="rId5"/>
+              </a:ext>
+            </a:extLst>
+          </a:blip>
+          <a:stretch>
+            <a:fillRect/>
+          </a:stretch>
+        </p:blipFill>
+        <p:spPr>
+          <a:xfrm>
+            <a:off x="6261043" y="3300809"/>
+            <a:ext cx="5275527" cy="943670"/>
+          </a:xfrm>
+          <a:prstGeom prst="rect">
+            <a:avLst/>
+          </a:prstGeom>
+        </p:spPr>
+      </p:pic>
+      <p:sp>
+        <p:nvSpPr>
+          <p:cNvPr id="9" name="Text 4">
+            <a:extLst>
+              <a:ext uri="{FF2B5EF4-FFF2-40B4-BE49-F238E27FC236}">
+                <a16:creationId xmlns:a16="http://schemas.microsoft.com/office/drawing/2014/main" id="{C602DD1E-DE0D-F381-DE1A-357FF0D07CBB}"/>
+              </a:ext>
+            </a:extLst>
+          </p:cNvPr>
+          <p:cNvSpPr/>
+          <p:nvPr/>
+        </p:nvSpPr>
+        <p:spPr>
+          <a:xfrm>
+            <a:off x="6486462" y="3450034"/>
+            <a:ext cx="4900887" cy="203498"/>
+          </a:xfrm>
+          <a:prstGeom prst="rect">
+            <a:avLst/>
+          </a:prstGeom>
+          <a:noFill/>
+          <a:ln/>
+        </p:spPr>
+        <p:txBody>
+          <a:bodyPr wrap="none" lIns="0" tIns="0" rIns="0" bIns="0" rtlCol="0" anchor="t"/>
+          <a:lstStyle/>
+          <a:p>
+            <a:pPr marL="0" indent="0" algn="l">
+              <a:lnSpc>
+                <a:spcPct val="104000"/>
+              </a:lnSpc>
+              <a:buNone/>
+            </a:pPr>
+            <a:r>
+              <a:rPr lang="en-US" sz="1250" b="1" dirty="0">
+                <a:solidFill>
+                  <a:srgbClr val="005A9B"/>
+                </a:solidFill>
+                <a:latin typeface="Inter Bold" pitchFamily="34" charset="0"/>
+                <a:ea typeface="Inter Bold" pitchFamily="34" charset="-122"/>
+                <a:cs typeface="Inter Bold" pitchFamily="34" charset="-120"/>
+              </a:rPr>
+              <a:t>Concurrent</a:t>
+            </a:r>
+            <a:endParaRPr lang="en-US" sz="1250" dirty="0"/>
+          </a:p>
+        </p:txBody>
+      </p:sp>
+      <p:sp>
+        <p:nvSpPr>
+          <p:cNvPr id="10" name="Text 5">
+            <a:extLst>
+              <a:ext uri="{FF2B5EF4-FFF2-40B4-BE49-F238E27FC236}">
+                <a16:creationId xmlns:a16="http://schemas.microsoft.com/office/drawing/2014/main" id="{D481DD82-A39A-8B15-C72B-846394829C4F}"/>
+              </a:ext>
+            </a:extLst>
+          </p:cNvPr>
+          <p:cNvSpPr/>
+          <p:nvPr/>
+        </p:nvSpPr>
+        <p:spPr>
+          <a:xfrm>
+            <a:off x="6486462" y="3743226"/>
+            <a:ext cx="4900887" cy="352028"/>
+          </a:xfrm>
+          <a:prstGeom prst="rect">
+            <a:avLst/>
+          </a:prstGeom>
+          <a:noFill/>
+          <a:ln/>
+        </p:spPr>
+        <p:txBody>
+          <a:bodyPr wrap="square" lIns="0" tIns="0" rIns="0" bIns="0" rtlCol="0" anchor="t">
+            <a:normAutofit fontScale="47500" lnSpcReduction="20000"/>
+          </a:bodyPr>
+          <a:lstStyle/>
+          <a:p>
+            <a:pPr>
+              <a:lnSpc>
+                <a:spcPct val="113000"/>
+              </a:lnSpc>
+            </a:pPr>
+            <a:r>
+              <a:rPr lang="en-HK" dirty="0"/>
+              <a:t>指系统具备</a:t>
+            </a:r>
+            <a:r>
+              <a:rPr lang="en-HK" b="1" dirty="0"/>
+              <a:t>处理多个任务</a:t>
+            </a:r>
+            <a:r>
+              <a:rPr lang="en-HK" dirty="0"/>
+              <a:t>的能力。它强调的是</a:t>
+            </a:r>
+            <a:r>
+              <a:rPr lang="en-HK" b="1" dirty="0"/>
+              <a:t>“</a:t>
+            </a:r>
+            <a:r>
+              <a:rPr lang="en-HK" b="1" dirty="0" err="1"/>
+              <a:t>交替执行</a:t>
+            </a:r>
+            <a:r>
+              <a:rPr lang="en-HK" b="1" dirty="0"/>
+              <a:t>”</a:t>
+            </a:r>
+            <a:r>
+              <a:rPr lang="en-HK" dirty="0"/>
+              <a:t>。</a:t>
+            </a:r>
+            <a:r>
+              <a:rPr lang="en-HK" dirty="0" err="1"/>
+              <a:t>在单核</a:t>
+            </a:r>
+            <a:r>
+              <a:rPr lang="en-HK" dirty="0"/>
+              <a:t> CPU </a:t>
+            </a:r>
+            <a:r>
+              <a:rPr lang="en-HK" dirty="0" err="1"/>
+              <a:t>上，通过极短的时间片切换（上下文切换</a:t>
+            </a:r>
+            <a:r>
+              <a:rPr lang="en-HK" dirty="0"/>
+              <a:t>），</a:t>
+            </a:r>
+            <a:r>
+              <a:rPr lang="en-HK" dirty="0" err="1"/>
+              <a:t>让多个任务看起来像在同时进行，但实际上同一瞬间只有一个任务在跑</a:t>
+            </a:r>
+            <a:r>
+              <a:rPr lang="en-HK" dirty="0"/>
+              <a:t>。</a:t>
+            </a:r>
+            <a:endParaRPr lang="en-US" sz="1000" dirty="0"/>
+          </a:p>
+        </p:txBody>
+      </p:sp>
+      <p:pic>
+        <p:nvPicPr>
+          <p:cNvPr id="11" name="Image 3" descr="preencoded.png">
+            <a:extLst>
+              <a:ext uri="{FF2B5EF4-FFF2-40B4-BE49-F238E27FC236}">
+                <a16:creationId xmlns:a16="http://schemas.microsoft.com/office/drawing/2014/main" id="{7B727F00-B58D-B73B-A356-9F336FA94A15}"/>
+              </a:ext>
+            </a:extLst>
+          </p:cNvPr>
+          <p:cNvPicPr>
+            <a:picLocks noChangeAspect="1"/>
+          </p:cNvPicPr>
+          <p:nvPr/>
+        </p:nvPicPr>
+        <p:blipFill>
+          <a:blip>
+            <a:extLst>
+              <a:ext uri="{96DAC541-7B7A-43D3-8B79-37D633B846F1}">
+                <asvg:svgBlip xmlns:asvg="http://schemas.microsoft.com/office/drawing/2016/SVG/main" r:embed="rId5"/>
+              </a:ext>
+            </a:extLst>
+          </a:blip>
+          <a:stretch>
+            <a:fillRect/>
+          </a:stretch>
+        </p:blipFill>
+        <p:spPr>
+          <a:xfrm>
+            <a:off x="6261043" y="4334173"/>
+            <a:ext cx="5275527" cy="943670"/>
+          </a:xfrm>
+          <a:prstGeom prst="rect">
+            <a:avLst/>
+          </a:prstGeom>
+        </p:spPr>
+      </p:pic>
+      <p:sp>
+        <p:nvSpPr>
+          <p:cNvPr id="12" name="Text 6">
+            <a:extLst>
+              <a:ext uri="{FF2B5EF4-FFF2-40B4-BE49-F238E27FC236}">
+                <a16:creationId xmlns:a16="http://schemas.microsoft.com/office/drawing/2014/main" id="{AE225893-6844-FBF3-FF3C-71E2929466D0}"/>
+              </a:ext>
+            </a:extLst>
+          </p:cNvPr>
+          <p:cNvSpPr/>
+          <p:nvPr/>
+        </p:nvSpPr>
+        <p:spPr>
+          <a:xfrm>
+            <a:off x="6486462" y="4483398"/>
+            <a:ext cx="4900887" cy="203498"/>
+          </a:xfrm>
+          <a:prstGeom prst="rect">
+            <a:avLst/>
+          </a:prstGeom>
+          <a:noFill/>
+          <a:ln/>
+        </p:spPr>
+        <p:txBody>
+          <a:bodyPr wrap="none" lIns="0" tIns="0" rIns="0" bIns="0" rtlCol="0" anchor="t"/>
+          <a:lstStyle/>
+          <a:p>
+            <a:pPr marL="0" indent="0" algn="l">
+              <a:lnSpc>
+                <a:spcPct val="104000"/>
+              </a:lnSpc>
+              <a:buNone/>
+            </a:pPr>
+            <a:r>
+              <a:rPr lang="en-US" sz="1250" b="1" dirty="0">
+                <a:solidFill>
+                  <a:srgbClr val="AE8D4B"/>
+                </a:solidFill>
+                <a:latin typeface="Inter Bold" pitchFamily="34" charset="0"/>
+                <a:ea typeface="Inter Bold" pitchFamily="34" charset="-122"/>
+                <a:cs typeface="Inter Bold" pitchFamily="34" charset="-120"/>
+              </a:rPr>
+              <a:t>Parallel</a:t>
+            </a:r>
+            <a:endParaRPr lang="en-US" sz="1250" dirty="0"/>
+          </a:p>
+        </p:txBody>
+      </p:sp>
+      <p:sp>
+        <p:nvSpPr>
+          <p:cNvPr id="13" name="Text 7">
+            <a:extLst>
+              <a:ext uri="{FF2B5EF4-FFF2-40B4-BE49-F238E27FC236}">
+                <a16:creationId xmlns:a16="http://schemas.microsoft.com/office/drawing/2014/main" id="{738B00F4-9346-817B-6704-63412ED91578}"/>
+              </a:ext>
+            </a:extLst>
+          </p:cNvPr>
+          <p:cNvSpPr/>
+          <p:nvPr/>
+        </p:nvSpPr>
+        <p:spPr>
+          <a:xfrm>
+            <a:off x="6486462" y="4776589"/>
+            <a:ext cx="4900887" cy="352028"/>
+          </a:xfrm>
+          <a:prstGeom prst="rect">
+            <a:avLst/>
+          </a:prstGeom>
+          <a:noFill/>
+          <a:ln/>
+        </p:spPr>
+        <p:txBody>
+          <a:bodyPr wrap="square" lIns="0" tIns="0" rIns="0" bIns="0" rtlCol="0" anchor="t">
+            <a:normAutofit fontScale="62500" lnSpcReduction="20000"/>
+          </a:bodyPr>
+          <a:lstStyle/>
+          <a:p>
+            <a:pPr lvl="0"/>
+            <a:r>
+              <a:rPr lang="en-HK" dirty="0"/>
+              <a:t>指系统具备</a:t>
+            </a:r>
+            <a:r>
+              <a:rPr lang="en-HK" b="1" dirty="0"/>
+              <a:t>同时执行</a:t>
+            </a:r>
+            <a:r>
+              <a:rPr lang="en-HK" dirty="0"/>
+              <a:t>多个任务的能力。它强调的是</a:t>
+            </a:r>
+            <a:r>
+              <a:rPr lang="en-HK" b="1" dirty="0"/>
+              <a:t>“</a:t>
+            </a:r>
+            <a:r>
+              <a:rPr lang="en-HK" b="1" dirty="0" err="1"/>
+              <a:t>同时进行</a:t>
+            </a:r>
+            <a:r>
+              <a:rPr lang="en-HK" b="1" dirty="0"/>
+              <a:t>”</a:t>
+            </a:r>
+            <a:r>
+              <a:rPr lang="en-HK" dirty="0"/>
+              <a:t>。</a:t>
+            </a:r>
+            <a:r>
+              <a:rPr lang="en-HK" dirty="0" err="1"/>
+              <a:t>必须在多核</a:t>
+            </a:r>
+            <a:r>
+              <a:rPr lang="en-HK" dirty="0"/>
+              <a:t> CPU </a:t>
+            </a:r>
+            <a:r>
+              <a:rPr lang="en-HK" dirty="0" err="1"/>
+              <a:t>或多处理器环境下，同一瞬间有多个任务真正在各自的核上运行</a:t>
+            </a:r>
+            <a:r>
+              <a:rPr lang="en-HK" dirty="0"/>
+              <a:t>。</a:t>
+            </a:r>
+          </a:p>
+        </p:txBody>
+      </p:sp>
+    </p:spTree>
+    <p:extLst>
+      <p:ext uri="{BB962C8B-B14F-4D97-AF65-F5344CB8AC3E}">
+        <p14:creationId xmlns:p14="http://schemas.microsoft.com/office/powerpoint/2010/main" val="3630779615"/>
+      </p:ext>
+    </p:extLst>
+  </p:cSld>
+  <p:clrMapOvr>
+    <a:masterClrMapping/>
+  </p:clrMapOvr>
+</p:sld>
+</file>
+
 <file path=ppt/theme/theme1.xml><?xml version="1.0" encoding="utf-8"?>
 <a:theme xmlns:a="http://schemas.openxmlformats.org/drawingml/2006/main" name="Office Theme">
   <a:themeElements>

</xml_diff>